<commit_message>
Actualiza evidencia bibliográfica y caso UPDS
</commit_message>
<xml_diff>
--- a/materiales/actividad-1/tema-01-uml-requisitos-v23.pptx
+++ b/materiales/actividad-1/tema-01-uml-requisitos-v23.pptx
@@ -11711,28 +11711,7 @@
             <a:spAutoFit/>
           </a:bodyPr>
           <a:lstStyle/>
-          <a:p>
-            <a:pPr algn="ctr">
-              <a:lnSpc>
-                <a:spcPct val="100000"/>
-              </a:lnSpc>
-              <a:spcBef>
-                <a:spcPts val="0"/>
-              </a:spcBef>
-              <a:spcAft>
-                <a:spcPts val="0"/>
-              </a:spcAft>
-            </a:pPr>
-            <a:r>
-              <a:rPr sz="1150" b="1" i="0">
-                <a:solidFill>
-                  <a:srgbClr val="1D4696"/>
-                </a:solidFill>
-                <a:latin typeface="Calibri"/>
-              </a:rPr>
-              <a:t>FOTOGRAFÍA DEL GRUPO</a:t>
-            </a:r>
-          </a:p>
+          <a:p/>
         </p:txBody>
       </p:sp>
       <p:sp>
@@ -12217,6 +12196,30 @@
           </a:p>
         </p:txBody>
       </p:sp>
+      <p:pic>
+        <p:nvPicPr>
+          <p:cNvPr id="21" name="Picture 20" descr="foto-grupal.jpeg"/>
+          <p:cNvPicPr>
+            <a:picLocks noChangeAspect="1"/>
+          </p:cNvPicPr>
+          <p:nvPr/>
+        </p:nvPicPr>
+        <p:blipFill>
+          <a:blip r:embed="rId2"/>
+          <a:stretch>
+            <a:fillRect/>
+          </a:stretch>
+        </p:blipFill>
+        <p:spPr>
+          <a:xfrm>
+            <a:off x="5239512" y="2148840"/>
+            <a:ext cx="1810512" cy="1357884"/>
+          </a:xfrm>
+          <a:prstGeom prst="rect">
+            <a:avLst/>
+          </a:prstGeom>
+        </p:spPr>
+      </p:pic>
     </p:spTree>
   </p:cSld>
   <p:clrMapOvr>
@@ -14958,7 +14961,7 @@
                 </a:solidFill>
                 <a:latin typeface="Calibri Light"/>
               </a:rPr>
-              <a:t>UML representa la arquitectura en componentes</a:t>
+              <a:t>Los componentes organizan una vista conceptual del catálogo</a:t>
             </a:r>
           </a:p>
         </p:txBody>
@@ -15050,7 +15053,7 @@
                 </a:solidFill>
                 <a:latin typeface="Calibri"/>
               </a:rPr>
-              <a:t>VISTA CONCEPTUAL BASADA EN LA TESIS DE LA BIBLIOTECA CENTRAL UPEA</a:t>
+              <a:t>MODELO CONCEPTUAL DEL CATÁLOGO PÚBLICO UPDS</a:t>
             </a:r>
           </a:p>
         </p:txBody>
@@ -15394,7 +15397,7 @@
                 </a:solidFill>
                 <a:latin typeface="Calibri"/>
               </a:rPr>
-              <a:t>PHP · lógica bibliotecaria</a:t>
+              <a:t>Interfaz de consulta</a:t>
             </a:r>
           </a:p>
         </p:txBody>
@@ -15566,7 +15569,7 @@
                 </a:solidFill>
                 <a:latin typeface="Calibri"/>
               </a:rPr>
-              <a:t>PostgreSQL · información</a:t>
+              <a:t>Registros y disponibilidad</a:t>
             </a:r>
           </a:p>
         </p:txBody>
@@ -15660,7 +15663,7 @@
                 </a:solidFill>
                 <a:latin typeface="Calibri"/>
               </a:rPr>
-              <a:t>1 · La interfaz solicita servicios a la aplicación.</a:t>
+              <a:t>1 · La interfaz presenta los registros consultables.</a:t>
             </a:r>
           </a:p>
         </p:txBody>
@@ -15706,7 +15709,7 @@
                 </a:solidFill>
                 <a:latin typeface="Calibri"/>
               </a:rPr>
-              <a:t>2 · La aplicación consulta o registra datos.</a:t>
+              <a:t>2 · La ficha muestra los datos publicados y sus ejemplares.</a:t>
             </a:r>
           </a:p>
         </p:txBody>
@@ -15752,7 +15755,7 @@
                 </a:solidFill>
                 <a:latin typeface="Calibri"/>
               </a:rPr>
-              <a:t>Rectángulo: componente de software     Flecha discontinua: dependencia</a:t>
+              <a:t>Rectángulo: bloque conceptual     Flecha: relación entre funciones</a:t>
             </a:r>
           </a:p>
         </p:txBody>
@@ -15832,7 +15835,7 @@
                 </a:solidFill>
                 <a:latin typeface="Calibri"/>
               </a:rPr>
-              <a:t>La tesis reporta web, PHP y PostgreSQL; UML organiza esa arquitectura en componentes.</a:t>
+              <a:t>La vista organiza la consulta de registros y ejemplares; no representa la arquitectura interna de UPDS.</a:t>
             </a:r>
           </a:p>
         </p:txBody>
@@ -15878,7 +15881,7 @@
                 </a:solidFill>
                 <a:latin typeface="Calibri"/>
               </a:rPr>
-              <a:t>Fuente: </a:t>
+              <a:t>Fuente: Catálogo público de Biblioteca UPDS · OMG, UML 2.5.1 · modelo analítico propuesto</a:t>
             </a:r>
             <a:r>
               <a:rPr sz="760" b="0" i="0">
@@ -15887,7 +15890,7 @@
                 </a:solidFill>
                 <a:latin typeface="Calibri"/>
               </a:rPr>
-              <a:t>Tintaya Villavicencio, R. (2013). Repositorio Institucional UPEA · OMG, UML 2.5.1  ·  as of 6 de octubre de 2026</a:t>
+              <a:t/>
             </a:r>
           </a:p>
         </p:txBody>
@@ -15985,7 +15988,7 @@
                 </a:solidFill>
                 <a:latin typeface="Calibri Light"/>
               </a:rPr>
-              <a:t>La UPEA documenta préstamos, reservas, reportes y estadísticas</a:t>
+              <a:t>El catálogo UPDS permite buscar y revisar registros bibliográficos</a:t>
             </a:r>
           </a:p>
         </p:txBody>
@@ -16031,7 +16034,7 @@
                 </a:solidFill>
                 <a:latin typeface="Calibri"/>
               </a:rPr>
-              <a:t>05 · CASO UPEA</a:t>
+              <a:t>05 · CASO REAL · UPDS</a:t>
             </a:r>
           </a:p>
         </p:txBody>
@@ -16077,7 +16080,7 @@
                 </a:solidFill>
                 <a:latin typeface="Calibri"/>
               </a:rPr>
-              <a:t>BIBLIOTECA CENTRAL · SISTEMA DE INFORMACIÓN CON INTERFAZ WEB</a:t>
+              <a:t>INTERACCIONES DISPONIBLES EN EL CATÁLOGO PÚBLICO</a:t>
             </a:r>
           </a:p>
         </p:txBody>
@@ -16157,7 +16160,8 @@
                 </a:solidFill>
                 <a:latin typeface="Calibri"/>
               </a:rPr>
-              <a:t>SISTEMA WEB</a:t>
+              <a:t>CATÁLOGO PÚBLICO
+Biblioteca UPDS</a:t>
             </a:r>
           </a:p>
           <a:p>
@@ -16179,7 +16183,7 @@
                 </a:solidFill>
                 <a:latin typeface="Calibri"/>
               </a:rPr>
-              <a:t>Biblioteca Central UPEA</a:t>
+              <a:t/>
             </a:r>
           </a:p>
         </p:txBody>
@@ -16347,7 +16351,7 @@
                 </a:solidFill>
                 <a:latin typeface="Calibri"/>
               </a:rPr>
-              <a:t>Préstamos</a:t>
+              <a:t>Búsquedas</a:t>
             </a:r>
           </a:p>
         </p:txBody>
@@ -16427,7 +16431,7 @@
                 </a:solidFill>
                 <a:latin typeface="Calibri"/>
               </a:rPr>
-              <a:t>Reservas remotas</a:t>
+              <a:t>Fichas bibliográficas</a:t>
             </a:r>
           </a:p>
         </p:txBody>
@@ -16507,7 +16511,7 @@
                 </a:solidFill>
                 <a:latin typeface="Calibri"/>
               </a:rPr>
-              <a:t>Reportes</a:t>
+              <a:t>Ejemplares</a:t>
             </a:r>
           </a:p>
         </p:txBody>
@@ -16587,7 +16591,7 @@
                 </a:solidFill>
                 <a:latin typeface="Calibri"/>
               </a:rPr>
-              <a:t>Estadísticas</a:t>
+              <a:t>Disponibilidad</a:t>
             </a:r>
           </a:p>
         </p:txBody>
@@ -16633,7 +16637,7 @@
                 </a:solidFill>
                 <a:latin typeface="Calibri"/>
               </a:rPr>
-              <a:t>MÉTODO Y TECNOLOGÍA DECLARADOS EN EL REGISTRO</a:t>
+              <a:t>DATOS Y FUNCIONES OBSERVABLES EN LAS FICHAS</a:t>
             </a:r>
           </a:p>
         </p:txBody>
@@ -16713,7 +16717,8 @@
                 </a:solidFill>
                 <a:latin typeface="Calibri"/>
               </a:rPr>
-              <a:t>UWE / UML</a:t>
+              <a:t>Búsqueda
+por título o autor</a:t>
             </a:r>
           </a:p>
           <a:p>
@@ -16735,7 +16740,7 @@
                 </a:solidFill>
                 <a:latin typeface="Calibri"/>
               </a:rPr>
-              <a:t>análisis y modelado</a:t>
+              <a:t/>
             </a:r>
           </a:p>
         </p:txBody>
@@ -16815,7 +16820,8 @@
                 </a:solidFill>
                 <a:latin typeface="Calibri"/>
               </a:rPr>
-              <a:t>PHP</a:t>
+              <a:t>Búsqueda
+registros bibliográficos</a:t>
             </a:r>
           </a:p>
           <a:p>
@@ -16837,7 +16843,7 @@
                 </a:solidFill>
                 <a:latin typeface="Calibri"/>
               </a:rPr>
-              <a:t>lógica de la aplicación</a:t>
+              <a:t/>
             </a:r>
           </a:p>
         </p:txBody>
@@ -16917,7 +16923,8 @@
                 </a:solidFill>
                 <a:latin typeface="Calibri"/>
               </a:rPr>
-              <a:t>PostgreSQL</a:t>
+              <a:t>Ejemplares
+disponibilidad consultable</a:t>
             </a:r>
           </a:p>
           <a:p>
@@ -16939,7 +16946,7 @@
                 </a:solidFill>
                 <a:latin typeface="Calibri"/>
               </a:rPr>
-              <a:t>almacenamiento de datos</a:t>
+              <a:t/>
             </a:r>
           </a:p>
         </p:txBody>
@@ -16987,7 +16994,7 @@
                 </a:solidFill>
                 <a:latin typeface="Calibri"/>
               </a:rPr>
-              <a:t>Abrir registro institucional UPEA ↗</a:t>
+              <a:t>Abrir catálogo público UPDS ↗</a:t>
             </a:r>
           </a:p>
         </p:txBody>
@@ -17033,7 +17040,7 @@
                 </a:solidFill>
                 <a:latin typeface="Calibri"/>
               </a:rPr>
-              <a:t>Fuente: </a:t>
+              <a:t>Fuente: Catálogo público de Biblioteca UPDS · búsqueda, fichas y ejemplares visibles · modelo analítico propuesto</a:t>
             </a:r>
             <a:r>
               <a:rPr sz="760" b="0" i="0">
@@ -17042,7 +17049,7 @@
                 </a:solidFill>
                 <a:latin typeface="Calibri"/>
               </a:rPr>
-              <a:t>Tintaya Villavicencio, R. (2013). Repositorio Institucional UPEA, ficha PG-0015  ·  as of 6 de octubre de 2026</a:t>
+              <a:t/>
             </a:r>
           </a:p>
         </p:txBody>
@@ -17140,7 +17147,7 @@
                 </a:solidFill>
                 <a:latin typeface="Calibri Light"/>
               </a:rPr>
-              <a:t>La tesis registra evaluación con McCall y pruebas de caja</a:t>
+              <a:t>La calidad del catálogo se expresa con criterios verificables</a:t>
             </a:r>
           </a:p>
         </p:txBody>
@@ -17381,7 +17388,8 @@
                 </a:solidFill>
                 <a:latin typeface="Calibri"/>
               </a:rPr>
-              <a:t>Sistema</a:t>
+              <a:t>Sistema
+catálogo público</a:t>
             </a:r>
           </a:p>
           <a:p>
@@ -17403,7 +17411,7 @@
                 </a:solidFill>
                 <a:latin typeface="Calibri"/>
               </a:rPr>
-              <a:t>biblioteca web</a:t>
+              <a:t/>
             </a:r>
           </a:p>
         </p:txBody>
@@ -17483,7 +17491,8 @@
                 </a:solidFill>
                 <a:latin typeface="Calibri"/>
               </a:rPr>
-              <a:t>Calidad</a:t>
+              <a:t>Calidad
+criterios de consulta</a:t>
             </a:r>
           </a:p>
           <a:p>
@@ -17505,7 +17514,7 @@
                 </a:solidFill>
                 <a:latin typeface="Calibri"/>
               </a:rPr>
-              <a:t>factores del modelo McCall</a:t>
+              <a:t/>
             </a:r>
           </a:p>
         </p:txBody>
@@ -17585,7 +17594,8 @@
                 </a:solidFill>
                 <a:latin typeface="Calibri"/>
               </a:rPr>
-              <a:t>Caja blanca</a:t>
+              <a:t>Estructura interna
+no publicada</a:t>
             </a:r>
           </a:p>
           <a:p>
@@ -17607,7 +17617,7 @@
                 </a:solidFill>
                 <a:latin typeface="Calibri"/>
               </a:rPr>
-              <a:t>estructura y rutas internas</a:t>
+              <a:t/>
             </a:r>
           </a:p>
         </p:txBody>
@@ -17687,7 +17697,8 @@
                 </a:solidFill>
                 <a:latin typeface="Calibri"/>
               </a:rPr>
-              <a:t>Caja negra</a:t>
+              <a:t>Prueba propuesta
+búsqueda y ficha</a:t>
             </a:r>
           </a:p>
           <a:p>
@@ -17709,7 +17720,7 @@
                 </a:solidFill>
                 <a:latin typeface="Calibri"/>
               </a:rPr>
-              <a:t>entradas y respuestas</a:t>
+              <a:t/>
             </a:r>
           </a:p>
         </p:txBody>
@@ -17789,7 +17800,7 @@
                 </a:solidFill>
                 <a:latin typeface="Calibri"/>
               </a:rPr>
-              <a:t>La tesis declara McCall y ambas pruebas. Su resumen no publica resultados ni métricas de evaluación.</a:t>
+              <a:t>Los criterios de aceptación son propuestas académicas; el catálogo público no expone resultados de pruebas internas ni métricas de desempeño.</a:t>
             </a:r>
           </a:p>
         </p:txBody>
@@ -17835,7 +17846,7 @@
                 </a:solidFill>
                 <a:latin typeface="Calibri"/>
               </a:rPr>
-              <a:t>Fuente: </a:t>
+              <a:t>Fuente: Catálogo público de Biblioteca UPDS · métricas y pruebas propuestas para este análisis</a:t>
             </a:r>
             <a:r>
               <a:rPr sz="760" b="0" i="0">
@@ -17844,7 +17855,7 @@
                 </a:solidFill>
                 <a:latin typeface="Calibri"/>
               </a:rPr>
-              <a:t>Tintaya Villavicencio, R. (2013). Resumen del proyecto de grado, UPEA  ·  as of 6 de octubre de 2026</a:t>
+              <a:t/>
             </a:r>
           </a:p>
         </p:txBody>

</xml_diff>

<commit_message>
Agrega nombres del equipo a las portadas
</commit_message>
<xml_diff>
--- a/materiales/actividad-1/tema-01-uml-requisitos-v23.pptx
+++ b/materiales/actividad-1/tema-01-uml-requisitos-v23.pptx
@@ -11801,7 +11801,7 @@
                 </a:solidFill>
                 <a:latin typeface="Calibri"/>
               </a:rPr>
-              <a:t>INTEGRANTE 1</a:t>
+              <a:t>Ashley Aguilar Perez</a:t>
             </a:r>
           </a:p>
         </p:txBody>
@@ -11879,7 +11879,7 @@
                 </a:solidFill>
                 <a:latin typeface="Calibri"/>
               </a:rPr>
-              <a:t>INTEGRANTE 2</a:t>
+              <a:t>Nicolas Soria Yabeta</a:t>
             </a:r>
           </a:p>
         </p:txBody>
@@ -11957,7 +11957,7 @@
                 </a:solidFill>
                 <a:latin typeface="Calibri"/>
               </a:rPr>
-              <a:t>INTEGRANTE 3</a:t>
+              <a:t>Erick Bravo Borges</a:t>
             </a:r>
           </a:p>
         </p:txBody>
@@ -12035,7 +12035,7 @@
                 </a:solidFill>
                 <a:latin typeface="Calibri"/>
               </a:rPr>
-              <a:t>INTEGRANTE 4</a:t>
+              <a:t>Jose Manuel Callecusi Guarachi</a:t>
             </a:r>
           </a:p>
         </p:txBody>
@@ -12113,7 +12113,7 @@
                 </a:solidFill>
                 <a:latin typeface="Calibri"/>
               </a:rPr>
-              <a:t>INTEGRANTE 5</a:t>
+              <a:t>Ruben Churqui Limachi</a:t>
             </a:r>
           </a:p>
         </p:txBody>

</xml_diff>

<commit_message>
Integra foto grupal en las presentaciones
</commit_message>
<xml_diff>
--- a/materiales/actividad-1/tema-01-uml-requisitos-v23.pptx
+++ b/materiales/actividad-1/tema-01-uml-requisitos-v23.pptx
@@ -11808,38 +11808,6 @@
       </p:sp>
       <p:sp>
         <p:nvSpPr>
-          <p:cNvPr id="11" name="Rectangle 10"/>
-          <p:cNvSpPr/>
-          <p:nvPr/>
-        </p:nvSpPr>
-        <p:spPr>
-          <a:xfrm>
-            <a:off x="3703320" y="4151376"/>
-            <a:ext cx="2267712" cy="201168"/>
-          </a:xfrm>
-          <a:prstGeom prst="rect">
-            <a:avLst/>
-          </a:prstGeom>
-          <a:solidFill>
-            <a:srgbClr val="FFFFFF"/>
-          </a:solidFill>
-          <a:ln w="8890">
-            <a:solidFill>
-              <a:srgbClr val="B8C9D9"/>
-            </a:solidFill>
-          </a:ln>
-          <a:effectLst/>
-        </p:spPr>
-        <p:txBody>
-          <a:bodyPr rtlCol="0" anchor="ctr"/>
-          <a:lstStyle/>
-          <a:p>
-            <a:pPr algn="ctr"/>
-          </a:p>
-        </p:txBody>
-      </p:sp>
-      <p:sp>
-        <p:nvSpPr>
           <p:cNvPr id="12" name="TextBox 11"/>
           <p:cNvSpPr txBox="1"/>
           <p:nvPr/>
@@ -11886,38 +11854,6 @@
       </p:sp>
       <p:sp>
         <p:nvSpPr>
-          <p:cNvPr id="13" name="Rectangle 12"/>
-          <p:cNvSpPr/>
-          <p:nvPr/>
-        </p:nvSpPr>
-        <p:spPr>
-          <a:xfrm>
-            <a:off x="6190488" y="4151376"/>
-            <a:ext cx="2267712" cy="201168"/>
-          </a:xfrm>
-          <a:prstGeom prst="rect">
-            <a:avLst/>
-          </a:prstGeom>
-          <a:solidFill>
-            <a:srgbClr val="FFFFFF"/>
-          </a:solidFill>
-          <a:ln w="8890">
-            <a:solidFill>
-              <a:srgbClr val="B8C9D9"/>
-            </a:solidFill>
-          </a:ln>
-          <a:effectLst/>
-        </p:spPr>
-        <p:txBody>
-          <a:bodyPr rtlCol="0" anchor="ctr"/>
-          <a:lstStyle/>
-          <a:p>
-            <a:pPr algn="ctr"/>
-          </a:p>
-        </p:txBody>
-      </p:sp>
-      <p:sp>
-        <p:nvSpPr>
           <p:cNvPr id="14" name="TextBox 13"/>
           <p:cNvSpPr txBox="1"/>
           <p:nvPr/>
@@ -11964,38 +11900,6 @@
       </p:sp>
       <p:sp>
         <p:nvSpPr>
-          <p:cNvPr id="15" name="Rectangle 14"/>
-          <p:cNvSpPr/>
-          <p:nvPr/>
-        </p:nvSpPr>
-        <p:spPr>
-          <a:xfrm>
-            <a:off x="3703320" y="4718304"/>
-            <a:ext cx="2267712" cy="201168"/>
-          </a:xfrm>
-          <a:prstGeom prst="rect">
-            <a:avLst/>
-          </a:prstGeom>
-          <a:solidFill>
-            <a:srgbClr val="FFFFFF"/>
-          </a:solidFill>
-          <a:ln w="8890">
-            <a:solidFill>
-              <a:srgbClr val="B8C9D9"/>
-            </a:solidFill>
-          </a:ln>
-          <a:effectLst/>
-        </p:spPr>
-        <p:txBody>
-          <a:bodyPr rtlCol="0" anchor="ctr"/>
-          <a:lstStyle/>
-          <a:p>
-            <a:pPr algn="ctr"/>
-          </a:p>
-        </p:txBody>
-      </p:sp>
-      <p:sp>
-        <p:nvSpPr>
           <p:cNvPr id="16" name="TextBox 15"/>
           <p:cNvSpPr txBox="1"/>
           <p:nvPr/>
@@ -12042,38 +11946,6 @@
       </p:sp>
       <p:sp>
         <p:nvSpPr>
-          <p:cNvPr id="17" name="Rectangle 16"/>
-          <p:cNvSpPr/>
-          <p:nvPr/>
-        </p:nvSpPr>
-        <p:spPr>
-          <a:xfrm>
-            <a:off x="6190488" y="4718304"/>
-            <a:ext cx="2267712" cy="201168"/>
-          </a:xfrm>
-          <a:prstGeom prst="rect">
-            <a:avLst/>
-          </a:prstGeom>
-          <a:solidFill>
-            <a:srgbClr val="FFFFFF"/>
-          </a:solidFill>
-          <a:ln w="8890">
-            <a:solidFill>
-              <a:srgbClr val="B8C9D9"/>
-            </a:solidFill>
-          </a:ln>
-          <a:effectLst/>
-        </p:spPr>
-        <p:txBody>
-          <a:bodyPr rtlCol="0" anchor="ctr"/>
-          <a:lstStyle/>
-          <a:p>
-            <a:pPr algn="ctr"/>
-          </a:p>
-        </p:txBody>
-      </p:sp>
-      <p:sp>
-        <p:nvSpPr>
           <p:cNvPr id="18" name="TextBox 17"/>
           <p:cNvSpPr txBox="1"/>
           <p:nvPr/>
@@ -12120,38 +11992,6 @@
       </p:sp>
       <p:sp>
         <p:nvSpPr>
-          <p:cNvPr id="19" name="Rectangle 18"/>
-          <p:cNvSpPr/>
-          <p:nvPr/>
-        </p:nvSpPr>
-        <p:spPr>
-          <a:xfrm>
-            <a:off x="3703320" y="5285232"/>
-            <a:ext cx="2267712" cy="201168"/>
-          </a:xfrm>
-          <a:prstGeom prst="rect">
-            <a:avLst/>
-          </a:prstGeom>
-          <a:solidFill>
-            <a:srgbClr val="FFFFFF"/>
-          </a:solidFill>
-          <a:ln w="8890">
-            <a:solidFill>
-              <a:srgbClr val="B8C9D9"/>
-            </a:solidFill>
-          </a:ln>
-          <a:effectLst/>
-        </p:spPr>
-        <p:txBody>
-          <a:bodyPr rtlCol="0" anchor="ctr"/>
-          <a:lstStyle/>
-          <a:p>
-            <a:pPr algn="ctr"/>
-          </a:p>
-        </p:txBody>
-      </p:sp>
-      <p:sp>
-        <p:nvSpPr>
           <p:cNvPr id="20" name="TextBox 19"/>
           <p:cNvSpPr txBox="1"/>
           <p:nvPr/>
@@ -12196,6 +12036,110 @@
           </a:p>
         </p:txBody>
       </p:sp>
+      <p:sp>
+        <p:nvSpPr>
+          <p:cNvPr id="22" name="Rounded Rectangle 21"/>
+          <p:cNvSpPr/>
+          <p:nvPr/>
+        </p:nvSpPr>
+        <p:spPr>
+          <a:gradFill rotWithShape="1">
+            <a:gsLst>
+              <a:gs pos="0">
+                <a:srgbClr val="16B9B0"/>
+              </a:gs>
+              <a:gs pos="42000">
+                <a:srgbClr val="F5C66A"/>
+              </a:gs>
+              <a:gs pos="72000">
+                <a:srgbClr val="6D7BF7"/>
+              </a:gs>
+              <a:gs pos="100000">
+                <a:srgbClr val="16B9B0"/>
+              </a:gs>
+            </a:gsLst>
+            <a:lin ang="2700000" scaled="1"/>
+          </a:gradFill>
+          <a:xfrm>
+            <a:off x="5230368" y="2084831"/>
+            <a:ext cx="1828800" cy="1426464"/>
+          </a:xfrm>
+          <a:prstGeom prst="roundRect">
+            <a:avLst/>
+          </a:prstGeom>
+          <a:ln w="13970">
+            <a:solidFill>
+              <a:srgbClr val="FFFFFF"/>
+            </a:solidFill>
+          </a:ln>
+        </p:spPr>
+        <p:style>
+          <a:lnRef idx="1">
+            <a:schemeClr val="accent1"/>
+          </a:lnRef>
+          <a:fillRef idx="3">
+            <a:schemeClr val="accent1"/>
+          </a:fillRef>
+          <a:effectRef idx="2">
+            <a:schemeClr val="accent1"/>
+          </a:effectRef>
+          <a:fontRef idx="minor">
+            <a:schemeClr val="lt1"/>
+          </a:fontRef>
+        </p:style>
+        <p:txBody>
+          <a:bodyPr rtlCol="0" anchor="ctr"/>
+          <a:lstStyle/>
+          <a:p>
+            <a:pPr algn="ctr"/>
+          </a:p>
+        </p:txBody>
+      </p:sp>
+      <p:sp>
+        <p:nvSpPr>
+          <p:cNvPr id="23" name="Rounded Rectangle 22"/>
+          <p:cNvSpPr/>
+          <p:nvPr/>
+        </p:nvSpPr>
+        <p:spPr>
+          <a:xfrm>
+            <a:off x="5253228" y="2107692"/>
+            <a:ext cx="1783080" cy="1380744"/>
+          </a:xfrm>
+          <a:prstGeom prst="roundRect">
+            <a:avLst/>
+          </a:prstGeom>
+          <a:solidFill>
+            <a:srgbClr val="F8FAFC"/>
+          </a:solidFill>
+          <a:ln w="10160">
+            <a:solidFill>
+              <a:srgbClr val="FFFFFF"/>
+            </a:solidFill>
+          </a:ln>
+        </p:spPr>
+        <p:style>
+          <a:lnRef idx="1">
+            <a:schemeClr val="accent1"/>
+          </a:lnRef>
+          <a:fillRef idx="3">
+            <a:schemeClr val="accent1"/>
+          </a:fillRef>
+          <a:effectRef idx="2">
+            <a:schemeClr val="accent1"/>
+          </a:effectRef>
+          <a:fontRef idx="minor">
+            <a:schemeClr val="lt1"/>
+          </a:fontRef>
+        </p:style>
+        <p:txBody>
+          <a:bodyPr rtlCol="0" anchor="ctr"/>
+          <a:lstStyle/>
+          <a:p>
+            <a:pPr algn="ctr"/>
+          </a:p>
+        </p:txBody>
+      </p:sp>
       <p:pic>
         <p:nvPicPr>
           <p:cNvPr id="21" name="Picture 20" descr="foto-grupal.jpeg"/>
@@ -12212,8 +12156,8 @@
         </p:blipFill>
         <p:spPr>
           <a:xfrm>
-            <a:off x="5239512" y="2148840"/>
-            <a:ext cx="1810512" cy="1357884"/>
+            <a:off x="5340096" y="2139696"/>
+            <a:ext cx="1609344" cy="1207008"/>
           </a:xfrm>
           <a:prstGeom prst="rect">
             <a:avLst/>
@@ -13305,6 +13249,134 @@
           </a:p>
         </p:txBody>
       </p:sp>
+      <p:sp>
+        <p:nvSpPr>
+          <p:cNvPr id="26" name="Rounded Rectangle 25"/>
+          <p:cNvSpPr/>
+          <p:nvPr/>
+        </p:nvSpPr>
+        <p:spPr>
+          <a:gradFill rotWithShape="1">
+            <a:gsLst>
+              <a:gs pos="0">
+                <a:srgbClr val="16B9B0"/>
+              </a:gs>
+              <a:gs pos="42000">
+                <a:srgbClr val="F5C66A"/>
+              </a:gs>
+              <a:gs pos="72000">
+                <a:srgbClr val="6D7BF7"/>
+              </a:gs>
+              <a:gs pos="100000">
+                <a:srgbClr val="16B9B0"/>
+              </a:gs>
+            </a:gsLst>
+            <a:lin ang="2700000" scaled="1"/>
+          </a:gradFill>
+          <a:xfrm>
+            <a:off x="8266175" y="6245352"/>
+            <a:ext cx="768096" cy="576072"/>
+          </a:xfrm>
+          <a:prstGeom prst="roundRect">
+            <a:avLst/>
+          </a:prstGeom>
+          <a:ln w="13970">
+            <a:solidFill>
+              <a:srgbClr val="FFFFFF"/>
+            </a:solidFill>
+          </a:ln>
+        </p:spPr>
+        <p:style>
+          <a:lnRef idx="1">
+            <a:schemeClr val="accent1"/>
+          </a:lnRef>
+          <a:fillRef idx="3">
+            <a:schemeClr val="accent1"/>
+          </a:fillRef>
+          <a:effectRef idx="2">
+            <a:schemeClr val="accent1"/>
+          </a:effectRef>
+          <a:fontRef idx="minor">
+            <a:schemeClr val="lt1"/>
+          </a:fontRef>
+        </p:style>
+        <p:txBody>
+          <a:bodyPr rtlCol="0" anchor="ctr"/>
+          <a:lstStyle/>
+          <a:p>
+            <a:pPr algn="ctr"/>
+          </a:p>
+        </p:txBody>
+      </p:sp>
+      <p:sp>
+        <p:nvSpPr>
+          <p:cNvPr id="27" name="Rounded Rectangle 26"/>
+          <p:cNvSpPr/>
+          <p:nvPr/>
+        </p:nvSpPr>
+        <p:spPr>
+          <a:xfrm>
+            <a:off x="8289036" y="6268212"/>
+            <a:ext cx="722375" cy="530352"/>
+          </a:xfrm>
+          <a:prstGeom prst="roundRect">
+            <a:avLst/>
+          </a:prstGeom>
+          <a:solidFill>
+            <a:srgbClr val="F8FAFC"/>
+          </a:solidFill>
+          <a:ln w="10160">
+            <a:solidFill>
+              <a:srgbClr val="FFFFFF"/>
+            </a:solidFill>
+          </a:ln>
+        </p:spPr>
+        <p:style>
+          <a:lnRef idx="1">
+            <a:schemeClr val="accent1"/>
+          </a:lnRef>
+          <a:fillRef idx="3">
+            <a:schemeClr val="accent1"/>
+          </a:fillRef>
+          <a:effectRef idx="2">
+            <a:schemeClr val="accent1"/>
+          </a:effectRef>
+          <a:fontRef idx="minor">
+            <a:schemeClr val="lt1"/>
+          </a:fontRef>
+        </p:style>
+        <p:txBody>
+          <a:bodyPr rtlCol="0" anchor="ctr"/>
+          <a:lstStyle/>
+          <a:p>
+            <a:pPr algn="ctr"/>
+          </a:p>
+        </p:txBody>
+      </p:sp>
+      <p:pic>
+        <p:nvPicPr>
+          <p:cNvPr id="28" name="Picture 27" descr="image.jpg"/>
+          <p:cNvPicPr>
+            <a:picLocks noChangeAspect="1"/>
+          </p:cNvPicPr>
+          <p:nvPr/>
+        </p:nvPicPr>
+        <p:blipFill>
+          <a:blip r:embed="rId2"/>
+          <a:stretch>
+            <a:fillRect/>
+          </a:stretch>
+        </p:blipFill>
+        <p:spPr>
+          <a:xfrm>
+            <a:off x="8321040" y="6286500"/>
+            <a:ext cx="658368" cy="493776"/>
+          </a:xfrm>
+          <a:prstGeom prst="rect">
+            <a:avLst/>
+          </a:prstGeom>
+        </p:spPr>
+      </p:pic>
     </p:spTree>
   </p:cSld>
   <p:clrMapOvr>
@@ -14199,6 +14271,134 @@
           </a:p>
         </p:txBody>
       </p:sp>
+      <p:sp>
+        <p:nvSpPr>
+          <p:cNvPr id="23" name="Rounded Rectangle 22"/>
+          <p:cNvSpPr/>
+          <p:nvPr/>
+        </p:nvSpPr>
+        <p:spPr>
+          <a:gradFill rotWithShape="1">
+            <a:gsLst>
+              <a:gs pos="0">
+                <a:srgbClr val="16B9B0"/>
+              </a:gs>
+              <a:gs pos="42000">
+                <a:srgbClr val="F5C66A"/>
+              </a:gs>
+              <a:gs pos="72000">
+                <a:srgbClr val="6D7BF7"/>
+              </a:gs>
+              <a:gs pos="100000">
+                <a:srgbClr val="16B9B0"/>
+              </a:gs>
+            </a:gsLst>
+            <a:lin ang="2700000" scaled="1"/>
+          </a:gradFill>
+          <a:xfrm>
+            <a:off x="8266175" y="6245352"/>
+            <a:ext cx="768096" cy="576072"/>
+          </a:xfrm>
+          <a:prstGeom prst="roundRect">
+            <a:avLst/>
+          </a:prstGeom>
+          <a:ln w="13970">
+            <a:solidFill>
+              <a:srgbClr val="FFFFFF"/>
+            </a:solidFill>
+          </a:ln>
+        </p:spPr>
+        <p:style>
+          <a:lnRef idx="1">
+            <a:schemeClr val="accent1"/>
+          </a:lnRef>
+          <a:fillRef idx="3">
+            <a:schemeClr val="accent1"/>
+          </a:fillRef>
+          <a:effectRef idx="2">
+            <a:schemeClr val="accent1"/>
+          </a:effectRef>
+          <a:fontRef idx="minor">
+            <a:schemeClr val="lt1"/>
+          </a:fontRef>
+        </p:style>
+        <p:txBody>
+          <a:bodyPr rtlCol="0" anchor="ctr"/>
+          <a:lstStyle/>
+          <a:p>
+            <a:pPr algn="ctr"/>
+          </a:p>
+        </p:txBody>
+      </p:sp>
+      <p:sp>
+        <p:nvSpPr>
+          <p:cNvPr id="24" name="Rounded Rectangle 23"/>
+          <p:cNvSpPr/>
+          <p:nvPr/>
+        </p:nvSpPr>
+        <p:spPr>
+          <a:xfrm>
+            <a:off x="8289036" y="6268212"/>
+            <a:ext cx="722375" cy="530352"/>
+          </a:xfrm>
+          <a:prstGeom prst="roundRect">
+            <a:avLst/>
+          </a:prstGeom>
+          <a:solidFill>
+            <a:srgbClr val="F8FAFC"/>
+          </a:solidFill>
+          <a:ln w="10160">
+            <a:solidFill>
+              <a:srgbClr val="FFFFFF"/>
+            </a:solidFill>
+          </a:ln>
+        </p:spPr>
+        <p:style>
+          <a:lnRef idx="1">
+            <a:schemeClr val="accent1"/>
+          </a:lnRef>
+          <a:fillRef idx="3">
+            <a:schemeClr val="accent1"/>
+          </a:fillRef>
+          <a:effectRef idx="2">
+            <a:schemeClr val="accent1"/>
+          </a:effectRef>
+          <a:fontRef idx="minor">
+            <a:schemeClr val="lt1"/>
+          </a:fontRef>
+        </p:style>
+        <p:txBody>
+          <a:bodyPr rtlCol="0" anchor="ctr"/>
+          <a:lstStyle/>
+          <a:p>
+            <a:pPr algn="ctr"/>
+          </a:p>
+        </p:txBody>
+      </p:sp>
+      <p:pic>
+        <p:nvPicPr>
+          <p:cNvPr id="25" name="Picture 24" descr="image.jpg"/>
+          <p:cNvPicPr>
+            <a:picLocks noChangeAspect="1"/>
+          </p:cNvPicPr>
+          <p:nvPr/>
+        </p:nvPicPr>
+        <p:blipFill>
+          <a:blip r:embed="rId2"/>
+          <a:stretch>
+            <a:fillRect/>
+          </a:stretch>
+        </p:blipFill>
+        <p:spPr>
+          <a:xfrm>
+            <a:off x="8321040" y="6286500"/>
+            <a:ext cx="658368" cy="493776"/>
+          </a:xfrm>
+          <a:prstGeom prst="rect">
+            <a:avLst/>
+          </a:prstGeom>
+        </p:spPr>
+      </p:pic>
     </p:spTree>
   </p:cSld>
   <p:clrMapOvr>
@@ -14868,6 +15068,134 @@
           </a:p>
         </p:txBody>
       </p:sp>
+      <p:sp>
+        <p:nvSpPr>
+          <p:cNvPr id="18" name="Rounded Rectangle 17"/>
+          <p:cNvSpPr/>
+          <p:nvPr/>
+        </p:nvSpPr>
+        <p:spPr>
+          <a:gradFill rotWithShape="1">
+            <a:gsLst>
+              <a:gs pos="0">
+                <a:srgbClr val="16B9B0"/>
+              </a:gs>
+              <a:gs pos="42000">
+                <a:srgbClr val="F5C66A"/>
+              </a:gs>
+              <a:gs pos="72000">
+                <a:srgbClr val="6D7BF7"/>
+              </a:gs>
+              <a:gs pos="100000">
+                <a:srgbClr val="16B9B0"/>
+              </a:gs>
+            </a:gsLst>
+            <a:lin ang="2700000" scaled="1"/>
+          </a:gradFill>
+          <a:xfrm>
+            <a:off x="8266175" y="6245352"/>
+            <a:ext cx="768096" cy="576072"/>
+          </a:xfrm>
+          <a:prstGeom prst="roundRect">
+            <a:avLst/>
+          </a:prstGeom>
+          <a:ln w="13970">
+            <a:solidFill>
+              <a:srgbClr val="FFFFFF"/>
+            </a:solidFill>
+          </a:ln>
+        </p:spPr>
+        <p:style>
+          <a:lnRef idx="1">
+            <a:schemeClr val="accent1"/>
+          </a:lnRef>
+          <a:fillRef idx="3">
+            <a:schemeClr val="accent1"/>
+          </a:fillRef>
+          <a:effectRef idx="2">
+            <a:schemeClr val="accent1"/>
+          </a:effectRef>
+          <a:fontRef idx="minor">
+            <a:schemeClr val="lt1"/>
+          </a:fontRef>
+        </p:style>
+        <p:txBody>
+          <a:bodyPr rtlCol="0" anchor="ctr"/>
+          <a:lstStyle/>
+          <a:p>
+            <a:pPr algn="ctr"/>
+          </a:p>
+        </p:txBody>
+      </p:sp>
+      <p:sp>
+        <p:nvSpPr>
+          <p:cNvPr id="19" name="Rounded Rectangle 18"/>
+          <p:cNvSpPr/>
+          <p:nvPr/>
+        </p:nvSpPr>
+        <p:spPr>
+          <a:xfrm>
+            <a:off x="8289036" y="6268212"/>
+            <a:ext cx="722375" cy="530352"/>
+          </a:xfrm>
+          <a:prstGeom prst="roundRect">
+            <a:avLst/>
+          </a:prstGeom>
+          <a:solidFill>
+            <a:srgbClr val="F8FAFC"/>
+          </a:solidFill>
+          <a:ln w="10160">
+            <a:solidFill>
+              <a:srgbClr val="FFFFFF"/>
+            </a:solidFill>
+          </a:ln>
+        </p:spPr>
+        <p:style>
+          <a:lnRef idx="1">
+            <a:schemeClr val="accent1"/>
+          </a:lnRef>
+          <a:fillRef idx="3">
+            <a:schemeClr val="accent1"/>
+          </a:fillRef>
+          <a:effectRef idx="2">
+            <a:schemeClr val="accent1"/>
+          </a:effectRef>
+          <a:fontRef idx="minor">
+            <a:schemeClr val="lt1"/>
+          </a:fontRef>
+        </p:style>
+        <p:txBody>
+          <a:bodyPr rtlCol="0" anchor="ctr"/>
+          <a:lstStyle/>
+          <a:p>
+            <a:pPr algn="ctr"/>
+          </a:p>
+        </p:txBody>
+      </p:sp>
+      <p:pic>
+        <p:nvPicPr>
+          <p:cNvPr id="20" name="Picture 19" descr="image.jpg"/>
+          <p:cNvPicPr>
+            <a:picLocks noChangeAspect="1"/>
+          </p:cNvPicPr>
+          <p:nvPr/>
+        </p:nvPicPr>
+        <p:blipFill>
+          <a:blip r:embed="rId2"/>
+          <a:stretch>
+            <a:fillRect/>
+          </a:stretch>
+        </p:blipFill>
+        <p:spPr>
+          <a:xfrm>
+            <a:off x="8321040" y="6286500"/>
+            <a:ext cx="658368" cy="493776"/>
+          </a:xfrm>
+          <a:prstGeom prst="rect">
+            <a:avLst/>
+          </a:prstGeom>
+        </p:spPr>
+      </p:pic>
     </p:spTree>
   </p:cSld>
   <p:clrMapOvr>
@@ -15895,6 +16223,134 @@
           </a:p>
         </p:txBody>
       </p:sp>
+      <p:sp>
+        <p:nvSpPr>
+          <p:cNvPr id="27" name="Rounded Rectangle 26"/>
+          <p:cNvSpPr/>
+          <p:nvPr/>
+        </p:nvSpPr>
+        <p:spPr>
+          <a:gradFill rotWithShape="1">
+            <a:gsLst>
+              <a:gs pos="0">
+                <a:srgbClr val="16B9B0"/>
+              </a:gs>
+              <a:gs pos="42000">
+                <a:srgbClr val="F5C66A"/>
+              </a:gs>
+              <a:gs pos="72000">
+                <a:srgbClr val="6D7BF7"/>
+              </a:gs>
+              <a:gs pos="100000">
+                <a:srgbClr val="16B9B0"/>
+              </a:gs>
+            </a:gsLst>
+            <a:lin ang="2700000" scaled="1"/>
+          </a:gradFill>
+          <a:xfrm>
+            <a:off x="8266175" y="6245352"/>
+            <a:ext cx="768096" cy="576072"/>
+          </a:xfrm>
+          <a:prstGeom prst="roundRect">
+            <a:avLst/>
+          </a:prstGeom>
+          <a:ln w="13970">
+            <a:solidFill>
+              <a:srgbClr val="FFFFFF"/>
+            </a:solidFill>
+          </a:ln>
+        </p:spPr>
+        <p:style>
+          <a:lnRef idx="1">
+            <a:schemeClr val="accent1"/>
+          </a:lnRef>
+          <a:fillRef idx="3">
+            <a:schemeClr val="accent1"/>
+          </a:fillRef>
+          <a:effectRef idx="2">
+            <a:schemeClr val="accent1"/>
+          </a:effectRef>
+          <a:fontRef idx="minor">
+            <a:schemeClr val="lt1"/>
+          </a:fontRef>
+        </p:style>
+        <p:txBody>
+          <a:bodyPr rtlCol="0" anchor="ctr"/>
+          <a:lstStyle/>
+          <a:p>
+            <a:pPr algn="ctr"/>
+          </a:p>
+        </p:txBody>
+      </p:sp>
+      <p:sp>
+        <p:nvSpPr>
+          <p:cNvPr id="28" name="Rounded Rectangle 27"/>
+          <p:cNvSpPr/>
+          <p:nvPr/>
+        </p:nvSpPr>
+        <p:spPr>
+          <a:xfrm>
+            <a:off x="8289036" y="6268212"/>
+            <a:ext cx="722375" cy="530352"/>
+          </a:xfrm>
+          <a:prstGeom prst="roundRect">
+            <a:avLst/>
+          </a:prstGeom>
+          <a:solidFill>
+            <a:srgbClr val="F8FAFC"/>
+          </a:solidFill>
+          <a:ln w="10160">
+            <a:solidFill>
+              <a:srgbClr val="FFFFFF"/>
+            </a:solidFill>
+          </a:ln>
+        </p:spPr>
+        <p:style>
+          <a:lnRef idx="1">
+            <a:schemeClr val="accent1"/>
+          </a:lnRef>
+          <a:fillRef idx="3">
+            <a:schemeClr val="accent1"/>
+          </a:fillRef>
+          <a:effectRef idx="2">
+            <a:schemeClr val="accent1"/>
+          </a:effectRef>
+          <a:fontRef idx="minor">
+            <a:schemeClr val="lt1"/>
+          </a:fontRef>
+        </p:style>
+        <p:txBody>
+          <a:bodyPr rtlCol="0" anchor="ctr"/>
+          <a:lstStyle/>
+          <a:p>
+            <a:pPr algn="ctr"/>
+          </a:p>
+        </p:txBody>
+      </p:sp>
+      <p:pic>
+        <p:nvPicPr>
+          <p:cNvPr id="29" name="Picture 28" descr="image.jpg"/>
+          <p:cNvPicPr>
+            <a:picLocks noChangeAspect="1"/>
+          </p:cNvPicPr>
+          <p:nvPr/>
+        </p:nvPicPr>
+        <p:blipFill>
+          <a:blip r:embed="rId2"/>
+          <a:stretch>
+            <a:fillRect/>
+          </a:stretch>
+        </p:blipFill>
+        <p:spPr>
+          <a:xfrm>
+            <a:off x="8321040" y="6286500"/>
+            <a:ext cx="658368" cy="493776"/>
+          </a:xfrm>
+          <a:prstGeom prst="rect">
+            <a:avLst/>
+          </a:prstGeom>
+        </p:spPr>
+      </p:pic>
     </p:spTree>
   </p:cSld>
   <p:clrMapOvr>
@@ -17054,6 +17510,134 @@
           </a:p>
         </p:txBody>
       </p:sp>
+      <p:sp>
+        <p:nvSpPr>
+          <p:cNvPr id="30" name="Rounded Rectangle 29"/>
+          <p:cNvSpPr/>
+          <p:nvPr/>
+        </p:nvSpPr>
+        <p:spPr>
+          <a:gradFill rotWithShape="1">
+            <a:gsLst>
+              <a:gs pos="0">
+                <a:srgbClr val="16B9B0"/>
+              </a:gs>
+              <a:gs pos="42000">
+                <a:srgbClr val="F5C66A"/>
+              </a:gs>
+              <a:gs pos="72000">
+                <a:srgbClr val="6D7BF7"/>
+              </a:gs>
+              <a:gs pos="100000">
+                <a:srgbClr val="16B9B0"/>
+              </a:gs>
+            </a:gsLst>
+            <a:lin ang="2700000" scaled="1"/>
+          </a:gradFill>
+          <a:xfrm>
+            <a:off x="8266175" y="6245352"/>
+            <a:ext cx="768096" cy="576072"/>
+          </a:xfrm>
+          <a:prstGeom prst="roundRect">
+            <a:avLst/>
+          </a:prstGeom>
+          <a:ln w="13970">
+            <a:solidFill>
+              <a:srgbClr val="FFFFFF"/>
+            </a:solidFill>
+          </a:ln>
+        </p:spPr>
+        <p:style>
+          <a:lnRef idx="1">
+            <a:schemeClr val="accent1"/>
+          </a:lnRef>
+          <a:fillRef idx="3">
+            <a:schemeClr val="accent1"/>
+          </a:fillRef>
+          <a:effectRef idx="2">
+            <a:schemeClr val="accent1"/>
+          </a:effectRef>
+          <a:fontRef idx="minor">
+            <a:schemeClr val="lt1"/>
+          </a:fontRef>
+        </p:style>
+        <p:txBody>
+          <a:bodyPr rtlCol="0" anchor="ctr"/>
+          <a:lstStyle/>
+          <a:p>
+            <a:pPr algn="ctr"/>
+          </a:p>
+        </p:txBody>
+      </p:sp>
+      <p:sp>
+        <p:nvSpPr>
+          <p:cNvPr id="31" name="Rounded Rectangle 30"/>
+          <p:cNvSpPr/>
+          <p:nvPr/>
+        </p:nvSpPr>
+        <p:spPr>
+          <a:xfrm>
+            <a:off x="8289036" y="6268212"/>
+            <a:ext cx="722375" cy="530352"/>
+          </a:xfrm>
+          <a:prstGeom prst="roundRect">
+            <a:avLst/>
+          </a:prstGeom>
+          <a:solidFill>
+            <a:srgbClr val="F8FAFC"/>
+          </a:solidFill>
+          <a:ln w="10160">
+            <a:solidFill>
+              <a:srgbClr val="FFFFFF"/>
+            </a:solidFill>
+          </a:ln>
+        </p:spPr>
+        <p:style>
+          <a:lnRef idx="1">
+            <a:schemeClr val="accent1"/>
+          </a:lnRef>
+          <a:fillRef idx="3">
+            <a:schemeClr val="accent1"/>
+          </a:fillRef>
+          <a:effectRef idx="2">
+            <a:schemeClr val="accent1"/>
+          </a:effectRef>
+          <a:fontRef idx="minor">
+            <a:schemeClr val="lt1"/>
+          </a:fontRef>
+        </p:style>
+        <p:txBody>
+          <a:bodyPr rtlCol="0" anchor="ctr"/>
+          <a:lstStyle/>
+          <a:p>
+            <a:pPr algn="ctr"/>
+          </a:p>
+        </p:txBody>
+      </p:sp>
+      <p:pic>
+        <p:nvPicPr>
+          <p:cNvPr id="32" name="Picture 31" descr="image.jpg"/>
+          <p:cNvPicPr>
+            <a:picLocks noChangeAspect="1"/>
+          </p:cNvPicPr>
+          <p:nvPr/>
+        </p:nvPicPr>
+        <p:blipFill>
+          <a:blip r:embed="rId3"/>
+          <a:stretch>
+            <a:fillRect/>
+          </a:stretch>
+        </p:blipFill>
+        <p:spPr>
+          <a:xfrm>
+            <a:off x="8321040" y="6286500"/>
+            <a:ext cx="658368" cy="493776"/>
+          </a:xfrm>
+          <a:prstGeom prst="rect">
+            <a:avLst/>
+          </a:prstGeom>
+        </p:spPr>
+      </p:pic>
     </p:spTree>
   </p:cSld>
   <p:clrMapOvr>
@@ -17860,6 +18444,134 @@
           </a:p>
         </p:txBody>
       </p:sp>
+      <p:sp>
+        <p:nvSpPr>
+          <p:cNvPr id="21" name="Rounded Rectangle 20"/>
+          <p:cNvSpPr/>
+          <p:nvPr/>
+        </p:nvSpPr>
+        <p:spPr>
+          <a:gradFill rotWithShape="1">
+            <a:gsLst>
+              <a:gs pos="0">
+                <a:srgbClr val="16B9B0"/>
+              </a:gs>
+              <a:gs pos="42000">
+                <a:srgbClr val="F5C66A"/>
+              </a:gs>
+              <a:gs pos="72000">
+                <a:srgbClr val="6D7BF7"/>
+              </a:gs>
+              <a:gs pos="100000">
+                <a:srgbClr val="16B9B0"/>
+              </a:gs>
+            </a:gsLst>
+            <a:lin ang="2700000" scaled="1"/>
+          </a:gradFill>
+          <a:xfrm>
+            <a:off x="8266175" y="6245352"/>
+            <a:ext cx="768096" cy="576072"/>
+          </a:xfrm>
+          <a:prstGeom prst="roundRect">
+            <a:avLst/>
+          </a:prstGeom>
+          <a:ln w="13970">
+            <a:solidFill>
+              <a:srgbClr val="FFFFFF"/>
+            </a:solidFill>
+          </a:ln>
+        </p:spPr>
+        <p:style>
+          <a:lnRef idx="1">
+            <a:schemeClr val="accent1"/>
+          </a:lnRef>
+          <a:fillRef idx="3">
+            <a:schemeClr val="accent1"/>
+          </a:fillRef>
+          <a:effectRef idx="2">
+            <a:schemeClr val="accent1"/>
+          </a:effectRef>
+          <a:fontRef idx="minor">
+            <a:schemeClr val="lt1"/>
+          </a:fontRef>
+        </p:style>
+        <p:txBody>
+          <a:bodyPr rtlCol="0" anchor="ctr"/>
+          <a:lstStyle/>
+          <a:p>
+            <a:pPr algn="ctr"/>
+          </a:p>
+        </p:txBody>
+      </p:sp>
+      <p:sp>
+        <p:nvSpPr>
+          <p:cNvPr id="22" name="Rounded Rectangle 21"/>
+          <p:cNvSpPr/>
+          <p:nvPr/>
+        </p:nvSpPr>
+        <p:spPr>
+          <a:xfrm>
+            <a:off x="8289036" y="6268212"/>
+            <a:ext cx="722375" cy="530352"/>
+          </a:xfrm>
+          <a:prstGeom prst="roundRect">
+            <a:avLst/>
+          </a:prstGeom>
+          <a:solidFill>
+            <a:srgbClr val="F8FAFC"/>
+          </a:solidFill>
+          <a:ln w="10160">
+            <a:solidFill>
+              <a:srgbClr val="FFFFFF"/>
+            </a:solidFill>
+          </a:ln>
+        </p:spPr>
+        <p:style>
+          <a:lnRef idx="1">
+            <a:schemeClr val="accent1"/>
+          </a:lnRef>
+          <a:fillRef idx="3">
+            <a:schemeClr val="accent1"/>
+          </a:fillRef>
+          <a:effectRef idx="2">
+            <a:schemeClr val="accent1"/>
+          </a:effectRef>
+          <a:fontRef idx="minor">
+            <a:schemeClr val="lt1"/>
+          </a:fontRef>
+        </p:style>
+        <p:txBody>
+          <a:bodyPr rtlCol="0" anchor="ctr"/>
+          <a:lstStyle/>
+          <a:p>
+            <a:pPr algn="ctr"/>
+          </a:p>
+        </p:txBody>
+      </p:sp>
+      <p:pic>
+        <p:nvPicPr>
+          <p:cNvPr id="23" name="Picture 22" descr="image.jpg"/>
+          <p:cNvPicPr>
+            <a:picLocks noChangeAspect="1"/>
+          </p:cNvPicPr>
+          <p:nvPr/>
+        </p:nvPicPr>
+        <p:blipFill>
+          <a:blip r:embed="rId2"/>
+          <a:stretch>
+            <a:fillRect/>
+          </a:stretch>
+        </p:blipFill>
+        <p:spPr>
+          <a:xfrm>
+            <a:off x="8321040" y="6286500"/>
+            <a:ext cx="658368" cy="493776"/>
+          </a:xfrm>
+          <a:prstGeom prst="rect">
+            <a:avLst/>
+          </a:prstGeom>
+        </p:spPr>
+      </p:pic>
     </p:spTree>
   </p:cSld>
   <p:clrMapOvr>
@@ -17953,7 +18665,7 @@
                 </a:solidFill>
                 <a:latin typeface="Calibri Light"/>
               </a:rPr>
-              <a:t>Tres libros en español disponibles en catálogos bolivianos</a:t>
+              <a:t>Referencias bibliográficas</a:t>
             </a:r>
           </a:p>
         </p:txBody>
@@ -18125,7 +18837,7 @@
                 </a:solidFill>
                 <a:latin typeface="Calibri"/>
               </a:rPr>
-              <a:t>DIGITAL · BIBLIOTECA UCB · LIBRO 1</a:t>
+              <a:t>DIGITAL · LIBRO 1</a:t>
             </a:r>
           </a:p>
         </p:txBody>
@@ -18345,7 +19057,7 @@
                 </a:solidFill>
                 <a:latin typeface="Calibri"/>
               </a:rPr>
-              <a:t>DIGITAL · BIBLIOTECA UCB · LIBRO 2</a:t>
+              <a:t>DIGITAL · LIBRO 2</a:t>
             </a:r>
           </a:p>
         </p:txBody>
@@ -18565,7 +19277,7 @@
                 </a:solidFill>
                 <a:latin typeface="Calibri"/>
               </a:rPr>
-              <a:t>IMPRESO · CATÁLOGO UPDS</a:t>
+              <a:t>IMPRESO · LIBRO 3</a:t>
             </a:r>
           </a:p>
         </p:txBody>
@@ -18705,66 +19417,139 @@
                 </a:solidFill>
                 <a:latin typeface="Calibri"/>
               </a:rPr>
-              <a:t>Consultar ficha UPDS ↗</a:t>
+              <a:t>Consultar ficha bibliográfica ↗</a:t>
             </a:r>
           </a:p>
         </p:txBody>
       </p:sp>
       <p:sp>
         <p:nvSpPr>
-          <p:cNvPr id="22" name="TextBox 21"/>
-          <p:cNvSpPr txBox="1"/>
+          <p:cNvPr id="23" name="Rounded Rectangle 22"/>
+          <p:cNvSpPr/>
           <p:nvPr/>
         </p:nvSpPr>
         <p:spPr>
-          <a:xfrm>
-            <a:off x="384048" y="6053328"/>
-            <a:ext cx="7818120" cy="220133"/>
+          <a:gradFill rotWithShape="1">
+            <a:gsLst>
+              <a:gs pos="0">
+                <a:srgbClr val="16B9B0"/>
+              </a:gs>
+              <a:gs pos="42000">
+                <a:srgbClr val="F5C66A"/>
+              </a:gs>
+              <a:gs pos="72000">
+                <a:srgbClr val="6D7BF7"/>
+              </a:gs>
+              <a:gs pos="100000">
+                <a:srgbClr val="16B9B0"/>
+              </a:gs>
+            </a:gsLst>
+            <a:lin ang="2700000" scaled="1"/>
+          </a:gradFill>
+          <a:xfrm>
+            <a:off x="8266175" y="6245352"/>
+            <a:ext cx="768096" cy="576072"/>
+          </a:xfrm>
+          <a:prstGeom prst="roundRect">
+            <a:avLst/>
+          </a:prstGeom>
+          <a:ln w="13970">
+            <a:solidFill>
+              <a:srgbClr val="FFFFFF"/>
+            </a:solidFill>
+          </a:ln>
+        </p:spPr>
+        <p:style>
+          <a:lnRef idx="1">
+            <a:schemeClr val="accent1"/>
+          </a:lnRef>
+          <a:fillRef idx="3">
+            <a:schemeClr val="accent1"/>
+          </a:fillRef>
+          <a:effectRef idx="2">
+            <a:schemeClr val="accent1"/>
+          </a:effectRef>
+          <a:fontRef idx="minor">
+            <a:schemeClr val="lt1"/>
+          </a:fontRef>
+        </p:style>
+        <p:txBody>
+          <a:bodyPr rtlCol="0" anchor="ctr"/>
+          <a:lstStyle/>
+          <a:p>
+            <a:pPr algn="ctr"/>
+          </a:p>
+        </p:txBody>
+      </p:sp>
+      <p:sp>
+        <p:nvSpPr>
+          <p:cNvPr id="24" name="Rounded Rectangle 23"/>
+          <p:cNvSpPr/>
+          <p:nvPr/>
+        </p:nvSpPr>
+        <p:spPr>
+          <a:xfrm>
+            <a:off x="8289036" y="6268212"/>
+            <a:ext cx="722375" cy="530352"/>
+          </a:xfrm>
+          <a:prstGeom prst="roundRect">
+            <a:avLst/>
+          </a:prstGeom>
+          <a:solidFill>
+            <a:srgbClr val="F8FAFC"/>
+          </a:solidFill>
+          <a:ln w="10160">
+            <a:solidFill>
+              <a:srgbClr val="FFFFFF"/>
+            </a:solidFill>
+          </a:ln>
+        </p:spPr>
+        <p:style>
+          <a:lnRef idx="1">
+            <a:schemeClr val="accent1"/>
+          </a:lnRef>
+          <a:fillRef idx="3">
+            <a:schemeClr val="accent1"/>
+          </a:fillRef>
+          <a:effectRef idx="2">
+            <a:schemeClr val="accent1"/>
+          </a:effectRef>
+          <a:fontRef idx="minor">
+            <a:schemeClr val="lt1"/>
+          </a:fontRef>
+        </p:style>
+        <p:txBody>
+          <a:bodyPr rtlCol="0" anchor="ctr"/>
+          <a:lstStyle/>
+          <a:p>
+            <a:pPr algn="ctr"/>
+          </a:p>
+        </p:txBody>
+      </p:sp>
+      <p:pic>
+        <p:nvPicPr>
+          <p:cNvPr id="25" name="Picture 24" descr="image.jpg"/>
+          <p:cNvPicPr>
+            <a:picLocks noChangeAspect="1"/>
+          </p:cNvPicPr>
+          <p:nvPr/>
+        </p:nvPicPr>
+        <p:blipFill>
+          <a:blip r:embed="rId5"/>
+          <a:stretch>
+            <a:fillRect/>
+          </a:stretch>
+        </p:blipFill>
+        <p:spPr>
+          <a:xfrm>
+            <a:off x="8321040" y="6286500"/>
+            <a:ext cx="658368" cy="493776"/>
           </a:xfrm>
           <a:prstGeom prst="rect">
             <a:avLst/>
           </a:prstGeom>
-          <a:noFill/>
-          <a:ln/>
-        </p:spPr>
-        <p:txBody>
-          <a:bodyPr wrap="square" anchor="t" lIns="25400" rIns="25400" tIns="25400" bIns="25400">
-            <a:spAutoFit/>
-          </a:bodyPr>
-          <a:lstStyle/>
-          <a:p>
-            <a:pPr algn="l">
-              <a:lnSpc>
-                <a:spcPct val="100000"/>
-              </a:lnSpc>
-              <a:spcBef>
-                <a:spcPts val="0"/>
-              </a:spcBef>
-              <a:spcAft>
-                <a:spcPts val="0"/>
-              </a:spcAft>
-            </a:pPr>
-            <a:r>
-              <a:rPr sz="760" b="1" i="0">
-                <a:solidFill>
-                  <a:srgbClr val="64748B"/>
-                </a:solidFill>
-                <a:latin typeface="Calibri"/>
-              </a:rPr>
-              <a:t>Fuente: </a:t>
-            </a:r>
-            <a:r>
-              <a:rPr sz="760" b="0" i="0">
-                <a:solidFill>
-                  <a:srgbClr val="64748B"/>
-                </a:solidFill>
-                <a:latin typeface="Calibri"/>
-              </a:rPr>
-              <a:t>Catálogo digital UCB Santa Cruz · Catálogo UPDS · referencias registradas por tema  ·  as of 6 de octubre de 2026</a:t>
-            </a:r>
-          </a:p>
-        </p:txBody>
-      </p:sp>
+        </p:spPr>
+      </p:pic>
     </p:spTree>
   </p:cSld>
   <p:clrMapOvr>

</xml_diff>

<commit_message>
Añade fotos de libros a las referencias finales
</commit_message>
<xml_diff>
--- a/materiales/actividad-1/tema-01-uml-requisitos-v23.pptx
+++ b/materiales/actividad-1/tema-01-uml-requisitos-v23.pptx
@@ -13249,134 +13249,6 @@
           </a:p>
         </p:txBody>
       </p:sp>
-      <p:sp>
-        <p:nvSpPr>
-          <p:cNvPr id="26" name="Rounded Rectangle 25"/>
-          <p:cNvSpPr/>
-          <p:nvPr/>
-        </p:nvSpPr>
-        <p:spPr>
-          <a:gradFill rotWithShape="1">
-            <a:gsLst>
-              <a:gs pos="0">
-                <a:srgbClr val="16B9B0"/>
-              </a:gs>
-              <a:gs pos="42000">
-                <a:srgbClr val="F5C66A"/>
-              </a:gs>
-              <a:gs pos="72000">
-                <a:srgbClr val="6D7BF7"/>
-              </a:gs>
-              <a:gs pos="100000">
-                <a:srgbClr val="16B9B0"/>
-              </a:gs>
-            </a:gsLst>
-            <a:lin ang="2700000" scaled="1"/>
-          </a:gradFill>
-          <a:xfrm>
-            <a:off x="8266175" y="6245352"/>
-            <a:ext cx="768096" cy="576072"/>
-          </a:xfrm>
-          <a:prstGeom prst="roundRect">
-            <a:avLst/>
-          </a:prstGeom>
-          <a:ln w="13970">
-            <a:solidFill>
-              <a:srgbClr val="FFFFFF"/>
-            </a:solidFill>
-          </a:ln>
-        </p:spPr>
-        <p:style>
-          <a:lnRef idx="1">
-            <a:schemeClr val="accent1"/>
-          </a:lnRef>
-          <a:fillRef idx="3">
-            <a:schemeClr val="accent1"/>
-          </a:fillRef>
-          <a:effectRef idx="2">
-            <a:schemeClr val="accent1"/>
-          </a:effectRef>
-          <a:fontRef idx="minor">
-            <a:schemeClr val="lt1"/>
-          </a:fontRef>
-        </p:style>
-        <p:txBody>
-          <a:bodyPr rtlCol="0" anchor="ctr"/>
-          <a:lstStyle/>
-          <a:p>
-            <a:pPr algn="ctr"/>
-          </a:p>
-        </p:txBody>
-      </p:sp>
-      <p:sp>
-        <p:nvSpPr>
-          <p:cNvPr id="27" name="Rounded Rectangle 26"/>
-          <p:cNvSpPr/>
-          <p:nvPr/>
-        </p:nvSpPr>
-        <p:spPr>
-          <a:xfrm>
-            <a:off x="8289036" y="6268212"/>
-            <a:ext cx="722375" cy="530352"/>
-          </a:xfrm>
-          <a:prstGeom prst="roundRect">
-            <a:avLst/>
-          </a:prstGeom>
-          <a:solidFill>
-            <a:srgbClr val="F8FAFC"/>
-          </a:solidFill>
-          <a:ln w="10160">
-            <a:solidFill>
-              <a:srgbClr val="FFFFFF"/>
-            </a:solidFill>
-          </a:ln>
-        </p:spPr>
-        <p:style>
-          <a:lnRef idx="1">
-            <a:schemeClr val="accent1"/>
-          </a:lnRef>
-          <a:fillRef idx="3">
-            <a:schemeClr val="accent1"/>
-          </a:fillRef>
-          <a:effectRef idx="2">
-            <a:schemeClr val="accent1"/>
-          </a:effectRef>
-          <a:fontRef idx="minor">
-            <a:schemeClr val="lt1"/>
-          </a:fontRef>
-        </p:style>
-        <p:txBody>
-          <a:bodyPr rtlCol="0" anchor="ctr"/>
-          <a:lstStyle/>
-          <a:p>
-            <a:pPr algn="ctr"/>
-          </a:p>
-        </p:txBody>
-      </p:sp>
-      <p:pic>
-        <p:nvPicPr>
-          <p:cNvPr id="28" name="Picture 27" descr="image.jpg"/>
-          <p:cNvPicPr>
-            <a:picLocks noChangeAspect="1"/>
-          </p:cNvPicPr>
-          <p:nvPr/>
-        </p:nvPicPr>
-        <p:blipFill>
-          <a:blip r:embed="rId2"/>
-          <a:stretch>
-            <a:fillRect/>
-          </a:stretch>
-        </p:blipFill>
-        <p:spPr>
-          <a:xfrm>
-            <a:off x="8321040" y="6286500"/>
-            <a:ext cx="658368" cy="493776"/>
-          </a:xfrm>
-          <a:prstGeom prst="rect">
-            <a:avLst/>
-          </a:prstGeom>
-        </p:spPr>
-      </p:pic>
     </p:spTree>
   </p:cSld>
   <p:clrMapOvr>
@@ -14271,134 +14143,6 @@
           </a:p>
         </p:txBody>
       </p:sp>
-      <p:sp>
-        <p:nvSpPr>
-          <p:cNvPr id="23" name="Rounded Rectangle 22"/>
-          <p:cNvSpPr/>
-          <p:nvPr/>
-        </p:nvSpPr>
-        <p:spPr>
-          <a:gradFill rotWithShape="1">
-            <a:gsLst>
-              <a:gs pos="0">
-                <a:srgbClr val="16B9B0"/>
-              </a:gs>
-              <a:gs pos="42000">
-                <a:srgbClr val="F5C66A"/>
-              </a:gs>
-              <a:gs pos="72000">
-                <a:srgbClr val="6D7BF7"/>
-              </a:gs>
-              <a:gs pos="100000">
-                <a:srgbClr val="16B9B0"/>
-              </a:gs>
-            </a:gsLst>
-            <a:lin ang="2700000" scaled="1"/>
-          </a:gradFill>
-          <a:xfrm>
-            <a:off x="8266175" y="6245352"/>
-            <a:ext cx="768096" cy="576072"/>
-          </a:xfrm>
-          <a:prstGeom prst="roundRect">
-            <a:avLst/>
-          </a:prstGeom>
-          <a:ln w="13970">
-            <a:solidFill>
-              <a:srgbClr val="FFFFFF"/>
-            </a:solidFill>
-          </a:ln>
-        </p:spPr>
-        <p:style>
-          <a:lnRef idx="1">
-            <a:schemeClr val="accent1"/>
-          </a:lnRef>
-          <a:fillRef idx="3">
-            <a:schemeClr val="accent1"/>
-          </a:fillRef>
-          <a:effectRef idx="2">
-            <a:schemeClr val="accent1"/>
-          </a:effectRef>
-          <a:fontRef idx="minor">
-            <a:schemeClr val="lt1"/>
-          </a:fontRef>
-        </p:style>
-        <p:txBody>
-          <a:bodyPr rtlCol="0" anchor="ctr"/>
-          <a:lstStyle/>
-          <a:p>
-            <a:pPr algn="ctr"/>
-          </a:p>
-        </p:txBody>
-      </p:sp>
-      <p:sp>
-        <p:nvSpPr>
-          <p:cNvPr id="24" name="Rounded Rectangle 23"/>
-          <p:cNvSpPr/>
-          <p:nvPr/>
-        </p:nvSpPr>
-        <p:spPr>
-          <a:xfrm>
-            <a:off x="8289036" y="6268212"/>
-            <a:ext cx="722375" cy="530352"/>
-          </a:xfrm>
-          <a:prstGeom prst="roundRect">
-            <a:avLst/>
-          </a:prstGeom>
-          <a:solidFill>
-            <a:srgbClr val="F8FAFC"/>
-          </a:solidFill>
-          <a:ln w="10160">
-            <a:solidFill>
-              <a:srgbClr val="FFFFFF"/>
-            </a:solidFill>
-          </a:ln>
-        </p:spPr>
-        <p:style>
-          <a:lnRef idx="1">
-            <a:schemeClr val="accent1"/>
-          </a:lnRef>
-          <a:fillRef idx="3">
-            <a:schemeClr val="accent1"/>
-          </a:fillRef>
-          <a:effectRef idx="2">
-            <a:schemeClr val="accent1"/>
-          </a:effectRef>
-          <a:fontRef idx="minor">
-            <a:schemeClr val="lt1"/>
-          </a:fontRef>
-        </p:style>
-        <p:txBody>
-          <a:bodyPr rtlCol="0" anchor="ctr"/>
-          <a:lstStyle/>
-          <a:p>
-            <a:pPr algn="ctr"/>
-          </a:p>
-        </p:txBody>
-      </p:sp>
-      <p:pic>
-        <p:nvPicPr>
-          <p:cNvPr id="25" name="Picture 24" descr="image.jpg"/>
-          <p:cNvPicPr>
-            <a:picLocks noChangeAspect="1"/>
-          </p:cNvPicPr>
-          <p:nvPr/>
-        </p:nvPicPr>
-        <p:blipFill>
-          <a:blip r:embed="rId2"/>
-          <a:stretch>
-            <a:fillRect/>
-          </a:stretch>
-        </p:blipFill>
-        <p:spPr>
-          <a:xfrm>
-            <a:off x="8321040" y="6286500"/>
-            <a:ext cx="658368" cy="493776"/>
-          </a:xfrm>
-          <a:prstGeom prst="rect">
-            <a:avLst/>
-          </a:prstGeom>
-        </p:spPr>
-      </p:pic>
     </p:spTree>
   </p:cSld>
   <p:clrMapOvr>
@@ -15068,134 +14812,6 @@
           </a:p>
         </p:txBody>
       </p:sp>
-      <p:sp>
-        <p:nvSpPr>
-          <p:cNvPr id="18" name="Rounded Rectangle 17"/>
-          <p:cNvSpPr/>
-          <p:nvPr/>
-        </p:nvSpPr>
-        <p:spPr>
-          <a:gradFill rotWithShape="1">
-            <a:gsLst>
-              <a:gs pos="0">
-                <a:srgbClr val="16B9B0"/>
-              </a:gs>
-              <a:gs pos="42000">
-                <a:srgbClr val="F5C66A"/>
-              </a:gs>
-              <a:gs pos="72000">
-                <a:srgbClr val="6D7BF7"/>
-              </a:gs>
-              <a:gs pos="100000">
-                <a:srgbClr val="16B9B0"/>
-              </a:gs>
-            </a:gsLst>
-            <a:lin ang="2700000" scaled="1"/>
-          </a:gradFill>
-          <a:xfrm>
-            <a:off x="8266175" y="6245352"/>
-            <a:ext cx="768096" cy="576072"/>
-          </a:xfrm>
-          <a:prstGeom prst="roundRect">
-            <a:avLst/>
-          </a:prstGeom>
-          <a:ln w="13970">
-            <a:solidFill>
-              <a:srgbClr val="FFFFFF"/>
-            </a:solidFill>
-          </a:ln>
-        </p:spPr>
-        <p:style>
-          <a:lnRef idx="1">
-            <a:schemeClr val="accent1"/>
-          </a:lnRef>
-          <a:fillRef idx="3">
-            <a:schemeClr val="accent1"/>
-          </a:fillRef>
-          <a:effectRef idx="2">
-            <a:schemeClr val="accent1"/>
-          </a:effectRef>
-          <a:fontRef idx="minor">
-            <a:schemeClr val="lt1"/>
-          </a:fontRef>
-        </p:style>
-        <p:txBody>
-          <a:bodyPr rtlCol="0" anchor="ctr"/>
-          <a:lstStyle/>
-          <a:p>
-            <a:pPr algn="ctr"/>
-          </a:p>
-        </p:txBody>
-      </p:sp>
-      <p:sp>
-        <p:nvSpPr>
-          <p:cNvPr id="19" name="Rounded Rectangle 18"/>
-          <p:cNvSpPr/>
-          <p:nvPr/>
-        </p:nvSpPr>
-        <p:spPr>
-          <a:xfrm>
-            <a:off x="8289036" y="6268212"/>
-            <a:ext cx="722375" cy="530352"/>
-          </a:xfrm>
-          <a:prstGeom prst="roundRect">
-            <a:avLst/>
-          </a:prstGeom>
-          <a:solidFill>
-            <a:srgbClr val="F8FAFC"/>
-          </a:solidFill>
-          <a:ln w="10160">
-            <a:solidFill>
-              <a:srgbClr val="FFFFFF"/>
-            </a:solidFill>
-          </a:ln>
-        </p:spPr>
-        <p:style>
-          <a:lnRef idx="1">
-            <a:schemeClr val="accent1"/>
-          </a:lnRef>
-          <a:fillRef idx="3">
-            <a:schemeClr val="accent1"/>
-          </a:fillRef>
-          <a:effectRef idx="2">
-            <a:schemeClr val="accent1"/>
-          </a:effectRef>
-          <a:fontRef idx="minor">
-            <a:schemeClr val="lt1"/>
-          </a:fontRef>
-        </p:style>
-        <p:txBody>
-          <a:bodyPr rtlCol="0" anchor="ctr"/>
-          <a:lstStyle/>
-          <a:p>
-            <a:pPr algn="ctr"/>
-          </a:p>
-        </p:txBody>
-      </p:sp>
-      <p:pic>
-        <p:nvPicPr>
-          <p:cNvPr id="20" name="Picture 19" descr="image.jpg"/>
-          <p:cNvPicPr>
-            <a:picLocks noChangeAspect="1"/>
-          </p:cNvPicPr>
-          <p:nvPr/>
-        </p:nvPicPr>
-        <p:blipFill>
-          <a:blip r:embed="rId2"/>
-          <a:stretch>
-            <a:fillRect/>
-          </a:stretch>
-        </p:blipFill>
-        <p:spPr>
-          <a:xfrm>
-            <a:off x="8321040" y="6286500"/>
-            <a:ext cx="658368" cy="493776"/>
-          </a:xfrm>
-          <a:prstGeom prst="rect">
-            <a:avLst/>
-          </a:prstGeom>
-        </p:spPr>
-      </p:pic>
     </p:spTree>
   </p:cSld>
   <p:clrMapOvr>
@@ -16223,134 +15839,6 @@
           </a:p>
         </p:txBody>
       </p:sp>
-      <p:sp>
-        <p:nvSpPr>
-          <p:cNvPr id="27" name="Rounded Rectangle 26"/>
-          <p:cNvSpPr/>
-          <p:nvPr/>
-        </p:nvSpPr>
-        <p:spPr>
-          <a:gradFill rotWithShape="1">
-            <a:gsLst>
-              <a:gs pos="0">
-                <a:srgbClr val="16B9B0"/>
-              </a:gs>
-              <a:gs pos="42000">
-                <a:srgbClr val="F5C66A"/>
-              </a:gs>
-              <a:gs pos="72000">
-                <a:srgbClr val="6D7BF7"/>
-              </a:gs>
-              <a:gs pos="100000">
-                <a:srgbClr val="16B9B0"/>
-              </a:gs>
-            </a:gsLst>
-            <a:lin ang="2700000" scaled="1"/>
-          </a:gradFill>
-          <a:xfrm>
-            <a:off x="8266175" y="6245352"/>
-            <a:ext cx="768096" cy="576072"/>
-          </a:xfrm>
-          <a:prstGeom prst="roundRect">
-            <a:avLst/>
-          </a:prstGeom>
-          <a:ln w="13970">
-            <a:solidFill>
-              <a:srgbClr val="FFFFFF"/>
-            </a:solidFill>
-          </a:ln>
-        </p:spPr>
-        <p:style>
-          <a:lnRef idx="1">
-            <a:schemeClr val="accent1"/>
-          </a:lnRef>
-          <a:fillRef idx="3">
-            <a:schemeClr val="accent1"/>
-          </a:fillRef>
-          <a:effectRef idx="2">
-            <a:schemeClr val="accent1"/>
-          </a:effectRef>
-          <a:fontRef idx="minor">
-            <a:schemeClr val="lt1"/>
-          </a:fontRef>
-        </p:style>
-        <p:txBody>
-          <a:bodyPr rtlCol="0" anchor="ctr"/>
-          <a:lstStyle/>
-          <a:p>
-            <a:pPr algn="ctr"/>
-          </a:p>
-        </p:txBody>
-      </p:sp>
-      <p:sp>
-        <p:nvSpPr>
-          <p:cNvPr id="28" name="Rounded Rectangle 27"/>
-          <p:cNvSpPr/>
-          <p:nvPr/>
-        </p:nvSpPr>
-        <p:spPr>
-          <a:xfrm>
-            <a:off x="8289036" y="6268212"/>
-            <a:ext cx="722375" cy="530352"/>
-          </a:xfrm>
-          <a:prstGeom prst="roundRect">
-            <a:avLst/>
-          </a:prstGeom>
-          <a:solidFill>
-            <a:srgbClr val="F8FAFC"/>
-          </a:solidFill>
-          <a:ln w="10160">
-            <a:solidFill>
-              <a:srgbClr val="FFFFFF"/>
-            </a:solidFill>
-          </a:ln>
-        </p:spPr>
-        <p:style>
-          <a:lnRef idx="1">
-            <a:schemeClr val="accent1"/>
-          </a:lnRef>
-          <a:fillRef idx="3">
-            <a:schemeClr val="accent1"/>
-          </a:fillRef>
-          <a:effectRef idx="2">
-            <a:schemeClr val="accent1"/>
-          </a:effectRef>
-          <a:fontRef idx="minor">
-            <a:schemeClr val="lt1"/>
-          </a:fontRef>
-        </p:style>
-        <p:txBody>
-          <a:bodyPr rtlCol="0" anchor="ctr"/>
-          <a:lstStyle/>
-          <a:p>
-            <a:pPr algn="ctr"/>
-          </a:p>
-        </p:txBody>
-      </p:sp>
-      <p:pic>
-        <p:nvPicPr>
-          <p:cNvPr id="29" name="Picture 28" descr="image.jpg"/>
-          <p:cNvPicPr>
-            <a:picLocks noChangeAspect="1"/>
-          </p:cNvPicPr>
-          <p:nvPr/>
-        </p:nvPicPr>
-        <p:blipFill>
-          <a:blip r:embed="rId2"/>
-          <a:stretch>
-            <a:fillRect/>
-          </a:stretch>
-        </p:blipFill>
-        <p:spPr>
-          <a:xfrm>
-            <a:off x="8321040" y="6286500"/>
-            <a:ext cx="658368" cy="493776"/>
-          </a:xfrm>
-          <a:prstGeom prst="rect">
-            <a:avLst/>
-          </a:prstGeom>
-        </p:spPr>
-      </p:pic>
     </p:spTree>
   </p:cSld>
   <p:clrMapOvr>
@@ -17510,134 +16998,6 @@
           </a:p>
         </p:txBody>
       </p:sp>
-      <p:sp>
-        <p:nvSpPr>
-          <p:cNvPr id="30" name="Rounded Rectangle 29"/>
-          <p:cNvSpPr/>
-          <p:nvPr/>
-        </p:nvSpPr>
-        <p:spPr>
-          <a:gradFill rotWithShape="1">
-            <a:gsLst>
-              <a:gs pos="0">
-                <a:srgbClr val="16B9B0"/>
-              </a:gs>
-              <a:gs pos="42000">
-                <a:srgbClr val="F5C66A"/>
-              </a:gs>
-              <a:gs pos="72000">
-                <a:srgbClr val="6D7BF7"/>
-              </a:gs>
-              <a:gs pos="100000">
-                <a:srgbClr val="16B9B0"/>
-              </a:gs>
-            </a:gsLst>
-            <a:lin ang="2700000" scaled="1"/>
-          </a:gradFill>
-          <a:xfrm>
-            <a:off x="8266175" y="6245352"/>
-            <a:ext cx="768096" cy="576072"/>
-          </a:xfrm>
-          <a:prstGeom prst="roundRect">
-            <a:avLst/>
-          </a:prstGeom>
-          <a:ln w="13970">
-            <a:solidFill>
-              <a:srgbClr val="FFFFFF"/>
-            </a:solidFill>
-          </a:ln>
-        </p:spPr>
-        <p:style>
-          <a:lnRef idx="1">
-            <a:schemeClr val="accent1"/>
-          </a:lnRef>
-          <a:fillRef idx="3">
-            <a:schemeClr val="accent1"/>
-          </a:fillRef>
-          <a:effectRef idx="2">
-            <a:schemeClr val="accent1"/>
-          </a:effectRef>
-          <a:fontRef idx="minor">
-            <a:schemeClr val="lt1"/>
-          </a:fontRef>
-        </p:style>
-        <p:txBody>
-          <a:bodyPr rtlCol="0" anchor="ctr"/>
-          <a:lstStyle/>
-          <a:p>
-            <a:pPr algn="ctr"/>
-          </a:p>
-        </p:txBody>
-      </p:sp>
-      <p:sp>
-        <p:nvSpPr>
-          <p:cNvPr id="31" name="Rounded Rectangle 30"/>
-          <p:cNvSpPr/>
-          <p:nvPr/>
-        </p:nvSpPr>
-        <p:spPr>
-          <a:xfrm>
-            <a:off x="8289036" y="6268212"/>
-            <a:ext cx="722375" cy="530352"/>
-          </a:xfrm>
-          <a:prstGeom prst="roundRect">
-            <a:avLst/>
-          </a:prstGeom>
-          <a:solidFill>
-            <a:srgbClr val="F8FAFC"/>
-          </a:solidFill>
-          <a:ln w="10160">
-            <a:solidFill>
-              <a:srgbClr val="FFFFFF"/>
-            </a:solidFill>
-          </a:ln>
-        </p:spPr>
-        <p:style>
-          <a:lnRef idx="1">
-            <a:schemeClr val="accent1"/>
-          </a:lnRef>
-          <a:fillRef idx="3">
-            <a:schemeClr val="accent1"/>
-          </a:fillRef>
-          <a:effectRef idx="2">
-            <a:schemeClr val="accent1"/>
-          </a:effectRef>
-          <a:fontRef idx="minor">
-            <a:schemeClr val="lt1"/>
-          </a:fontRef>
-        </p:style>
-        <p:txBody>
-          <a:bodyPr rtlCol="0" anchor="ctr"/>
-          <a:lstStyle/>
-          <a:p>
-            <a:pPr algn="ctr"/>
-          </a:p>
-        </p:txBody>
-      </p:sp>
-      <p:pic>
-        <p:nvPicPr>
-          <p:cNvPr id="32" name="Picture 31" descr="image.jpg"/>
-          <p:cNvPicPr>
-            <a:picLocks noChangeAspect="1"/>
-          </p:cNvPicPr>
-          <p:nvPr/>
-        </p:nvPicPr>
-        <p:blipFill>
-          <a:blip r:embed="rId3"/>
-          <a:stretch>
-            <a:fillRect/>
-          </a:stretch>
-        </p:blipFill>
-        <p:spPr>
-          <a:xfrm>
-            <a:off x="8321040" y="6286500"/>
-            <a:ext cx="658368" cy="493776"/>
-          </a:xfrm>
-          <a:prstGeom prst="rect">
-            <a:avLst/>
-          </a:prstGeom>
-        </p:spPr>
-      </p:pic>
     </p:spTree>
   </p:cSld>
   <p:clrMapOvr>
@@ -18444,134 +17804,6 @@
           </a:p>
         </p:txBody>
       </p:sp>
-      <p:sp>
-        <p:nvSpPr>
-          <p:cNvPr id="21" name="Rounded Rectangle 20"/>
-          <p:cNvSpPr/>
-          <p:nvPr/>
-        </p:nvSpPr>
-        <p:spPr>
-          <a:gradFill rotWithShape="1">
-            <a:gsLst>
-              <a:gs pos="0">
-                <a:srgbClr val="16B9B0"/>
-              </a:gs>
-              <a:gs pos="42000">
-                <a:srgbClr val="F5C66A"/>
-              </a:gs>
-              <a:gs pos="72000">
-                <a:srgbClr val="6D7BF7"/>
-              </a:gs>
-              <a:gs pos="100000">
-                <a:srgbClr val="16B9B0"/>
-              </a:gs>
-            </a:gsLst>
-            <a:lin ang="2700000" scaled="1"/>
-          </a:gradFill>
-          <a:xfrm>
-            <a:off x="8266175" y="6245352"/>
-            <a:ext cx="768096" cy="576072"/>
-          </a:xfrm>
-          <a:prstGeom prst="roundRect">
-            <a:avLst/>
-          </a:prstGeom>
-          <a:ln w="13970">
-            <a:solidFill>
-              <a:srgbClr val="FFFFFF"/>
-            </a:solidFill>
-          </a:ln>
-        </p:spPr>
-        <p:style>
-          <a:lnRef idx="1">
-            <a:schemeClr val="accent1"/>
-          </a:lnRef>
-          <a:fillRef idx="3">
-            <a:schemeClr val="accent1"/>
-          </a:fillRef>
-          <a:effectRef idx="2">
-            <a:schemeClr val="accent1"/>
-          </a:effectRef>
-          <a:fontRef idx="minor">
-            <a:schemeClr val="lt1"/>
-          </a:fontRef>
-        </p:style>
-        <p:txBody>
-          <a:bodyPr rtlCol="0" anchor="ctr"/>
-          <a:lstStyle/>
-          <a:p>
-            <a:pPr algn="ctr"/>
-          </a:p>
-        </p:txBody>
-      </p:sp>
-      <p:sp>
-        <p:nvSpPr>
-          <p:cNvPr id="22" name="Rounded Rectangle 21"/>
-          <p:cNvSpPr/>
-          <p:nvPr/>
-        </p:nvSpPr>
-        <p:spPr>
-          <a:xfrm>
-            <a:off x="8289036" y="6268212"/>
-            <a:ext cx="722375" cy="530352"/>
-          </a:xfrm>
-          <a:prstGeom prst="roundRect">
-            <a:avLst/>
-          </a:prstGeom>
-          <a:solidFill>
-            <a:srgbClr val="F8FAFC"/>
-          </a:solidFill>
-          <a:ln w="10160">
-            <a:solidFill>
-              <a:srgbClr val="FFFFFF"/>
-            </a:solidFill>
-          </a:ln>
-        </p:spPr>
-        <p:style>
-          <a:lnRef idx="1">
-            <a:schemeClr val="accent1"/>
-          </a:lnRef>
-          <a:fillRef idx="3">
-            <a:schemeClr val="accent1"/>
-          </a:fillRef>
-          <a:effectRef idx="2">
-            <a:schemeClr val="accent1"/>
-          </a:effectRef>
-          <a:fontRef idx="minor">
-            <a:schemeClr val="lt1"/>
-          </a:fontRef>
-        </p:style>
-        <p:txBody>
-          <a:bodyPr rtlCol="0" anchor="ctr"/>
-          <a:lstStyle/>
-          <a:p>
-            <a:pPr algn="ctr"/>
-          </a:p>
-        </p:txBody>
-      </p:sp>
-      <p:pic>
-        <p:nvPicPr>
-          <p:cNvPr id="23" name="Picture 22" descr="image.jpg"/>
-          <p:cNvPicPr>
-            <a:picLocks noChangeAspect="1"/>
-          </p:cNvPicPr>
-          <p:nvPr/>
-        </p:nvPicPr>
-        <p:blipFill>
-          <a:blip r:embed="rId2"/>
-          <a:stretch>
-            <a:fillRect/>
-          </a:stretch>
-        </p:blipFill>
-        <p:spPr>
-          <a:xfrm>
-            <a:off x="8321040" y="6286500"/>
-            <a:ext cx="658368" cy="493776"/>
-          </a:xfrm>
-          <a:prstGeom prst="rect">
-            <a:avLst/>
-          </a:prstGeom>
-        </p:spPr>
-      </p:pic>
     </p:spTree>
   </p:cSld>
   <p:clrMapOvr>
@@ -19245,7 +18477,7 @@
         <p:spPr>
           <a:xfrm>
             <a:off x="749808" y="4059936"/>
-            <a:ext cx="7589520" cy="182880"/>
+            <a:ext cx="6400800" cy="182880"/>
           </a:xfrm>
           <a:prstGeom prst="rect">
             <a:avLst/>
@@ -19291,7 +18523,7 @@
         <p:spPr>
           <a:xfrm>
             <a:off x="749808" y="4306824"/>
-            <a:ext cx="7543800" cy="292608"/>
+            <a:ext cx="6355080" cy="292608"/>
           </a:xfrm>
           <a:prstGeom prst="rect">
             <a:avLst/>
@@ -19323,7 +18555,7 @@
                 </a:solidFill>
                 <a:latin typeface="Calibri"/>
               </a:rPr>
-              <a:t>Análisis y diseño orientado a objetos con UML y Rational Rose</a:t>
+              <a:t>UML con Rational Rose</a:t>
             </a:r>
           </a:p>
         </p:txBody>
@@ -19337,7 +18569,7 @@
         <p:spPr>
           <a:xfrm>
             <a:off x="749808" y="4654296"/>
-            <a:ext cx="6583680" cy="201168"/>
+            <a:ext cx="6355080" cy="201168"/>
           </a:xfrm>
           <a:prstGeom prst="rect">
             <a:avLst/>
@@ -19369,7 +18601,7 @@
                 </a:solidFill>
                 <a:latin typeface="Calibri"/>
               </a:rPr>
-              <a:t>Sergio Matsukawa · Empresa Editora Macro · 2004 · 520 p.</a:t>
+              <a:t>Gesvin Romero Moreno · Grupo Editorial Megabyte · 1.ª ed., 2004 · pp. 17–19</a:t>
             </a:r>
           </a:p>
         </p:txBody>
@@ -19384,8 +18616,8 @@
         </p:nvSpPr>
         <p:spPr>
           <a:xfrm>
-            <a:off x="6903720" y="4937760"/>
-            <a:ext cx="1417320" cy="164592"/>
+            <a:off x="749808" y="4937760"/>
+            <a:ext cx="2286000" cy="164592"/>
           </a:xfrm>
           <a:prstGeom prst="rect">
             <a:avLst/>
@@ -19424,7 +18656,7 @@
       </p:sp>
       <p:sp>
         <p:nvSpPr>
-          <p:cNvPr id="23" name="Rounded Rectangle 22"/>
+          <p:cNvPr id="22" name="Rounded Rectangle 21"/>
           <p:cNvSpPr/>
           <p:nvPr/>
         </p:nvSpPr>
@@ -19447,8 +18679,8 @@
             <a:lin ang="2700000" scaled="1"/>
           </a:gradFill>
           <a:xfrm>
-            <a:off x="8266175" y="6245352"/>
-            <a:ext cx="768096" cy="576072"/>
+            <a:off x="7370064" y="4005072"/>
+            <a:ext cx="877824" cy="1133856"/>
           </a:xfrm>
           <a:prstGeom prst="roundRect">
             <a:avLst/>
@@ -19483,14 +18715,14 @@
       </p:sp>
       <p:sp>
         <p:nvSpPr>
-          <p:cNvPr id="24" name="Rounded Rectangle 23"/>
+          <p:cNvPr id="23" name="Rounded Rectangle 22"/>
           <p:cNvSpPr/>
           <p:nvPr/>
         </p:nvSpPr>
         <p:spPr>
           <a:xfrm>
-            <a:off x="8289036" y="6268212"/>
-            <a:ext cx="722375" cy="530352"/>
+            <a:off x="7392924" y="4027932"/>
+            <a:ext cx="832103" cy="1088136"/>
           </a:xfrm>
           <a:prstGeom prst="roundRect">
             <a:avLst/>
@@ -19528,22 +18760,22 @@
       </p:sp>
       <p:pic>
         <p:nvPicPr>
-          <p:cNvPr id="25" name="Picture 24" descr="image.jpg"/>
+          <p:cNvPr id="24" name="Picture 23" descr="Portada de UML con Rational Rose, de Gesvin Romero Moreno."/>
           <p:cNvPicPr>
             <a:picLocks noChangeAspect="1"/>
           </p:cNvPicPr>
           <p:nvPr/>
         </p:nvPicPr>
         <p:blipFill>
-          <a:blip r:embed="rId5"/>
+          <a:blip r:embed="rId6"/>
           <a:stretch>
             <a:fillRect/>
           </a:stretch>
         </p:blipFill>
         <p:spPr>
           <a:xfrm>
-            <a:off x="8321040" y="6286500"/>
-            <a:ext cx="658368" cy="493776"/>
+            <a:off x="7424927" y="4059936"/>
+            <a:ext cx="768096" cy="1024128"/>
           </a:xfrm>
           <a:prstGeom prst="rect">
             <a:avLst/>

</xml_diff>

<commit_message>
Mejora portadas y referencias de actividad 1
</commit_message>
<xml_diff>
--- a/materiales/actividad-1/tema-01-uml-requisitos-v23.pptx
+++ b/materiales/actividad-1/tema-01-uml-requisitos-v23.pptx
@@ -11525,8 +11525,8 @@
         </p:nvSpPr>
         <p:spPr>
           <a:xfrm>
-            <a:off x="3657600" y="402336"/>
-            <a:ext cx="5074920" cy="219456"/>
+            <a:off x="594360" y="438912"/>
+            <a:ext cx="7955279" cy="237744"/>
           </a:xfrm>
           <a:prstGeom prst="rect">
             <a:avLst/>
@@ -11535,7 +11535,150 @@
           <a:ln/>
         </p:spPr>
         <p:txBody>
-          <a:bodyPr wrap="square" anchor="t" lIns="25400" rIns="25400" tIns="25400" bIns="25400">
+          <a:bodyPr wrap="square" anchor="ctr" lIns="18288" rIns="18288" tIns="9144" bIns="9144">
+            <a:spAutoFit/>
+          </a:bodyPr>
+          <a:lstStyle/>
+          <a:p>
+            <a:pPr algn="l"/>
+            <a:r>
+              <a:rPr sz="1300" b="1"/>
+              <a:t>ACTIVIDAD 1 · TEMA 01</a:t>
+            </a:r>
+          </a:p>
+        </p:txBody>
+      </p:sp>
+      <p:sp>
+        <p:nvSpPr>
+          <p:cNvPr id="5" name="TextBox 4"/>
+          <p:cNvSpPr txBox="1"/>
+          <p:nvPr/>
+        </p:nvSpPr>
+        <p:spPr>
+          <a:xfrm>
+            <a:off x="594360" y="749808"/>
+            <a:ext cx="7955279" cy="658368"/>
+          </a:xfrm>
+          <a:prstGeom prst="rect">
+            <a:avLst/>
+          </a:prstGeom>
+          <a:noFill/>
+          <a:ln/>
+        </p:spPr>
+        <p:txBody>
+          <a:bodyPr wrap="square" anchor="ctr" lIns="18288" rIns="18288" tIns="9144" bIns="9144">
+            <a:spAutoFit/>
+          </a:bodyPr>
+          <a:lstStyle/>
+          <a:p>
+            <a:pPr algn="l">
+              <a:lnSpc>
+                <a:spcPct val="96000"/>
+              </a:lnSpc>
+              <a:spcBef>
+                <a:spcPts val="0"/>
+              </a:spcBef>
+              <a:spcAft>
+                <a:spcPts val="0"/>
+              </a:spcAft>
+            </a:pPr>
+            <a:r>
+              <a:rPr sz="2900" b="1" i="0">
+                <a:solidFill>
+                  <a:srgbClr val="1D4696"/>
+                </a:solidFill>
+                <a:latin typeface="Calibri Light"/>
+              </a:rPr>
+              <a:t>UML Y REQUISITOS DEL SISTEMA</a:t>
+            </a:r>
+          </a:p>
+        </p:txBody>
+      </p:sp>
+      <p:sp>
+        <p:nvSpPr>
+          <p:cNvPr id="6" name="TextBox 5"/>
+          <p:cNvSpPr txBox="1"/>
+          <p:nvPr/>
+        </p:nvSpPr>
+        <p:spPr>
+          <a:xfrm>
+            <a:off x="594360" y="1481328"/>
+            <a:ext cx="7955279" cy="347472"/>
+          </a:xfrm>
+          <a:prstGeom prst="rect">
+            <a:avLst/>
+          </a:prstGeom>
+          <a:noFill/>
+          <a:ln/>
+        </p:spPr>
+        <p:txBody>
+          <a:bodyPr wrap="square" anchor="ctr" lIns="18288" rIns="18288" tIns="9144" bIns="9144">
+            <a:spAutoFit/>
+          </a:bodyPr>
+          <a:lstStyle/>
+          <a:p>
+            <a:pPr algn="l"/>
+            <a:r>
+              <a:rPr sz="1800" b="1">
+                <a:solidFill>
+                  <a:srgbClr val="18488B"/>
+                </a:solidFill>
+              </a:rPr>
+              <a:t>SISTEMAS DE INFORMACIÓN I</a:t>
+            </a:r>
+          </a:p>
+        </p:txBody>
+      </p:sp>
+      <p:sp>
+        <p:nvSpPr>
+          <p:cNvPr id="9" name="TextBox 8"/>
+          <p:cNvSpPr txBox="1"/>
+          <p:nvPr/>
+        </p:nvSpPr>
+        <p:spPr>
+          <a:xfrm>
+            <a:off x="5074920" y="2148840"/>
+            <a:ext cx="3474720" cy="310896"/>
+          </a:xfrm>
+          <a:prstGeom prst="rect">
+            <a:avLst/>
+          </a:prstGeom>
+          <a:noFill/>
+          <a:ln/>
+        </p:spPr>
+        <p:txBody>
+          <a:bodyPr wrap="square" anchor="ctr" lIns="18288" rIns="18288" tIns="9144" bIns="9144">
+            <a:spAutoFit/>
+          </a:bodyPr>
+          <a:lstStyle/>
+          <a:p>
+            <a:pPr algn="l"/>
+            <a:r>
+              <a:rPr sz="1600" b="1"/>
+              <a:t>INTEGRANTES</a:t>
+            </a:r>
+          </a:p>
+        </p:txBody>
+      </p:sp>
+      <p:sp>
+        <p:nvSpPr>
+          <p:cNvPr id="10" name="TextBox 9"/>
+          <p:cNvSpPr txBox="1"/>
+          <p:nvPr/>
+        </p:nvSpPr>
+        <p:spPr>
+          <a:xfrm>
+            <a:off x="5074920" y="2633472"/>
+            <a:ext cx="3566160" cy="292608"/>
+          </a:xfrm>
+          <a:prstGeom prst="rect">
+            <a:avLst/>
+          </a:prstGeom>
+          <a:noFill/>
+          <a:ln/>
+        </p:spPr>
+        <p:txBody>
+          <a:bodyPr wrap="square" anchor="ctr" lIns="18288" rIns="18288" tIns="9144" bIns="9144">
             <a:spAutoFit/>
           </a:bodyPr>
           <a:lstStyle/>
@@ -11552,27 +11695,27 @@
               </a:spcAft>
             </a:pPr>
             <a:r>
-              <a:rPr sz="1050" b="1" i="0">
+              <a:rPr sz="1400" b="0" i="0">
                 <a:solidFill>
-                  <a:srgbClr val="0075A9"/>
+                  <a:srgbClr val="64748B"/>
                 </a:solidFill>
                 <a:latin typeface="Calibri"/>
               </a:rPr>
-              <a:t>ACTIVIDAD 1 · TEMA 01</a:t>
+              <a:t>Ashley Aguilar Perez</a:t>
             </a:r>
           </a:p>
         </p:txBody>
       </p:sp>
       <p:sp>
         <p:nvSpPr>
-          <p:cNvPr id="5" name="TextBox 4"/>
+          <p:cNvPr id="12" name="TextBox 11"/>
           <p:cNvSpPr txBox="1"/>
           <p:nvPr/>
         </p:nvSpPr>
         <p:spPr>
           <a:xfrm>
-            <a:off x="3657600" y="713232"/>
-            <a:ext cx="5074920" cy="850392"/>
+            <a:off x="5074920" y="3054096"/>
+            <a:ext cx="3566160" cy="292608"/>
           </a:xfrm>
           <a:prstGeom prst="rect">
             <a:avLst/>
@@ -11581,53 +11724,7 @@
           <a:ln/>
         </p:spPr>
         <p:txBody>
-          <a:bodyPr wrap="square" anchor="t" lIns="25400" rIns="25400" tIns="25400" bIns="25400">
-            <a:spAutoFit/>
-          </a:bodyPr>
-          <a:lstStyle/>
-          <a:p>
-            <a:pPr algn="l">
-              <a:lnSpc>
-                <a:spcPct val="96000"/>
-              </a:lnSpc>
-              <a:spcBef>
-                <a:spcPts val="0"/>
-              </a:spcBef>
-              <a:spcAft>
-                <a:spcPts val="0"/>
-              </a:spcAft>
-            </a:pPr>
-            <a:r>
-              <a:rPr sz="2250" b="1" i="0">
-                <a:solidFill>
-                  <a:srgbClr val="1D4696"/>
-                </a:solidFill>
-                <a:latin typeface="Calibri Light"/>
-              </a:rPr>
-              <a:t>UML Y REQUISITOS DEL SISTEMA</a:t>
-            </a:r>
-          </a:p>
-        </p:txBody>
-      </p:sp>
-      <p:sp>
-        <p:nvSpPr>
-          <p:cNvPr id="6" name="TextBox 5"/>
-          <p:cNvSpPr txBox="1"/>
-          <p:nvPr/>
-        </p:nvSpPr>
-        <p:spPr>
-          <a:xfrm>
-            <a:off x="3675887" y="1618488"/>
-            <a:ext cx="4983480" cy="420624"/>
-          </a:xfrm>
-          <a:prstGeom prst="rect">
-            <a:avLst/>
-          </a:prstGeom>
-          <a:noFill/>
-          <a:ln/>
-        </p:spPr>
-        <p:txBody>
-          <a:bodyPr wrap="square" anchor="t" lIns="25400" rIns="25400" tIns="25400" bIns="25400">
+          <a:bodyPr wrap="square" anchor="ctr" lIns="18288" rIns="18288" tIns="9144" bIns="9144">
             <a:spAutoFit/>
           </a:bodyPr>
           <a:lstStyle/>
@@ -11644,61 +11741,27 @@
               </a:spcAft>
             </a:pPr>
             <a:r>
-              <a:rPr sz="1320" b="1" i="0">
+              <a:rPr sz="1400" b="0" i="0">
                 <a:solidFill>
-                  <a:srgbClr val="1E293B"/>
+                  <a:srgbClr val="64748B"/>
                 </a:solidFill>
                 <a:latin typeface="Calibri"/>
               </a:rPr>
-              <a:t>Sistemas de Información I</a:t>
+              <a:t>Nicolas Soria Yabeta</a:t>
             </a:r>
           </a:p>
         </p:txBody>
       </p:sp>
       <p:sp>
         <p:nvSpPr>
-          <p:cNvPr id="7" name="Rounded Rectangle 6"/>
-          <p:cNvSpPr/>
-          <p:nvPr/>
-        </p:nvSpPr>
-        <p:spPr>
-          <a:xfrm>
-            <a:off x="3703320" y="2148840"/>
-            <a:ext cx="4892040" cy="1353312"/>
-          </a:xfrm>
-          <a:prstGeom prst="roundRect">
-            <a:avLst>
-              <a:gd name="adj" fmla="val 8000"/>
-            </a:avLst>
-          </a:prstGeom>
-          <a:solidFill>
-            <a:srgbClr val="E7F5FA"/>
-          </a:solidFill>
-          <a:ln w="19050">
-            <a:solidFill>
-              <a:srgbClr val="0075A9"/>
-            </a:solidFill>
-          </a:ln>
-          <a:effectLst/>
-        </p:spPr>
-        <p:txBody>
-          <a:bodyPr rtlCol="0" anchor="ctr"/>
-          <a:lstStyle/>
-          <a:p>
-            <a:pPr algn="ctr"/>
-          </a:p>
-        </p:txBody>
-      </p:sp>
-      <p:sp>
-        <p:nvSpPr>
-          <p:cNvPr id="8" name="TextBox 7"/>
+          <p:cNvPr id="14" name="TextBox 13"/>
           <p:cNvSpPr txBox="1"/>
           <p:nvPr/>
         </p:nvSpPr>
         <p:spPr>
           <a:xfrm>
-            <a:off x="3840480" y="2633472"/>
-            <a:ext cx="4617720" cy="310896"/>
+            <a:off x="5074920" y="3474720"/>
+            <a:ext cx="3566160" cy="292608"/>
           </a:xfrm>
           <a:prstGeom prst="rect">
             <a:avLst/>
@@ -11707,32 +11770,7 @@
           <a:ln/>
         </p:spPr>
         <p:txBody>
-          <a:bodyPr wrap="square" anchor="ctr" lIns="25400" rIns="25400" tIns="25400" bIns="25400">
-            <a:spAutoFit/>
-          </a:bodyPr>
-          <a:lstStyle/>
-          <a:p/>
-        </p:txBody>
-      </p:sp>
-      <p:sp>
-        <p:nvSpPr>
-          <p:cNvPr id="9" name="TextBox 8"/>
-          <p:cNvSpPr txBox="1"/>
-          <p:nvPr/>
-        </p:nvSpPr>
-        <p:spPr>
-          <a:xfrm>
-            <a:off x="3703320" y="3630168"/>
-            <a:ext cx="4800600" cy="274320"/>
-          </a:xfrm>
-          <a:prstGeom prst="rect">
-            <a:avLst/>
-          </a:prstGeom>
-          <a:noFill/>
-          <a:ln/>
-        </p:spPr>
-        <p:txBody>
-          <a:bodyPr wrap="square" anchor="t" lIns="25400" rIns="25400" tIns="25400" bIns="25400">
+          <a:bodyPr wrap="square" anchor="ctr" lIns="18288" rIns="18288" tIns="9144" bIns="9144">
             <a:spAutoFit/>
           </a:bodyPr>
           <a:lstStyle/>
@@ -11749,27 +11787,27 @@
               </a:spcAft>
             </a:pPr>
             <a:r>
-              <a:rPr sz="1000" b="1" i="0">
+              <a:rPr sz="1400" b="0" i="0">
                 <a:solidFill>
-                  <a:srgbClr val="0075A9"/>
+                  <a:srgbClr val="64748B"/>
                 </a:solidFill>
                 <a:latin typeface="Calibri"/>
               </a:rPr>
-              <a:t>INTEGRANTES</a:t>
+              <a:t>Erick Bravo Borges</a:t>
             </a:r>
           </a:p>
         </p:txBody>
       </p:sp>
       <p:sp>
         <p:nvSpPr>
-          <p:cNvPr id="10" name="TextBox 9"/>
+          <p:cNvPr id="16" name="TextBox 15"/>
           <p:cNvSpPr txBox="1"/>
           <p:nvPr/>
         </p:nvSpPr>
         <p:spPr>
           <a:xfrm>
-            <a:off x="3703320" y="3959352"/>
-            <a:ext cx="2286000" cy="164592"/>
+            <a:off x="5074920" y="3895344"/>
+            <a:ext cx="3566160" cy="292608"/>
           </a:xfrm>
           <a:prstGeom prst="rect">
             <a:avLst/>
@@ -11778,7 +11816,7 @@
           <a:ln/>
         </p:spPr>
         <p:txBody>
-          <a:bodyPr wrap="square" anchor="t" lIns="25400" rIns="25400" tIns="25400" bIns="25400">
+          <a:bodyPr wrap="square" anchor="ctr" lIns="18288" rIns="18288" tIns="9144" bIns="9144">
             <a:spAutoFit/>
           </a:bodyPr>
           <a:lstStyle/>
@@ -11795,27 +11833,27 @@
               </a:spcAft>
             </a:pPr>
             <a:r>
-              <a:rPr sz="830" b="1" i="0">
+              <a:rPr sz="1400" b="0" i="0">
                 <a:solidFill>
                   <a:srgbClr val="64748B"/>
                 </a:solidFill>
                 <a:latin typeface="Calibri"/>
               </a:rPr>
-              <a:t>Ashley Aguilar Perez</a:t>
+              <a:t>Jose Manuel Callecusi Guarachi</a:t>
             </a:r>
           </a:p>
         </p:txBody>
       </p:sp>
       <p:sp>
         <p:nvSpPr>
-          <p:cNvPr id="12" name="TextBox 11"/>
+          <p:cNvPr id="18" name="TextBox 17"/>
           <p:cNvSpPr txBox="1"/>
           <p:nvPr/>
         </p:nvSpPr>
         <p:spPr>
           <a:xfrm>
-            <a:off x="6190488" y="3959352"/>
-            <a:ext cx="2286000" cy="164592"/>
+            <a:off x="5074920" y="4315968"/>
+            <a:ext cx="3566160" cy="292608"/>
           </a:xfrm>
           <a:prstGeom prst="rect">
             <a:avLst/>
@@ -11824,7 +11862,7 @@
           <a:ln/>
         </p:spPr>
         <p:txBody>
-          <a:bodyPr wrap="square" anchor="t" lIns="25400" rIns="25400" tIns="25400" bIns="25400">
+          <a:bodyPr wrap="square" anchor="ctr" lIns="18288" rIns="18288" tIns="9144" bIns="9144">
             <a:spAutoFit/>
           </a:bodyPr>
           <a:lstStyle/>
@@ -11841,145 +11879,7 @@
               </a:spcAft>
             </a:pPr>
             <a:r>
-              <a:rPr sz="830" b="1" i="0">
-                <a:solidFill>
-                  <a:srgbClr val="64748B"/>
-                </a:solidFill>
-                <a:latin typeface="Calibri"/>
-              </a:rPr>
-              <a:t>Nicolas Soria Yabeta</a:t>
-            </a:r>
-          </a:p>
-        </p:txBody>
-      </p:sp>
-      <p:sp>
-        <p:nvSpPr>
-          <p:cNvPr id="14" name="TextBox 13"/>
-          <p:cNvSpPr txBox="1"/>
-          <p:nvPr/>
-        </p:nvSpPr>
-        <p:spPr>
-          <a:xfrm>
-            <a:off x="3703320" y="4526280"/>
-            <a:ext cx="2286000" cy="164592"/>
-          </a:xfrm>
-          <a:prstGeom prst="rect">
-            <a:avLst/>
-          </a:prstGeom>
-          <a:noFill/>
-          <a:ln/>
-        </p:spPr>
-        <p:txBody>
-          <a:bodyPr wrap="square" anchor="t" lIns="25400" rIns="25400" tIns="25400" bIns="25400">
-            <a:spAutoFit/>
-          </a:bodyPr>
-          <a:lstStyle/>
-          <a:p>
-            <a:pPr algn="l">
-              <a:lnSpc>
-                <a:spcPct val="100000"/>
-              </a:lnSpc>
-              <a:spcBef>
-                <a:spcPts val="0"/>
-              </a:spcBef>
-              <a:spcAft>
-                <a:spcPts val="0"/>
-              </a:spcAft>
-            </a:pPr>
-            <a:r>
-              <a:rPr sz="830" b="1" i="0">
-                <a:solidFill>
-                  <a:srgbClr val="64748B"/>
-                </a:solidFill>
-                <a:latin typeface="Calibri"/>
-              </a:rPr>
-              <a:t>Erick Bravo Borges</a:t>
-            </a:r>
-          </a:p>
-        </p:txBody>
-      </p:sp>
-      <p:sp>
-        <p:nvSpPr>
-          <p:cNvPr id="16" name="TextBox 15"/>
-          <p:cNvSpPr txBox="1"/>
-          <p:nvPr/>
-        </p:nvSpPr>
-        <p:spPr>
-          <a:xfrm>
-            <a:off x="6190488" y="4526280"/>
-            <a:ext cx="2286000" cy="164592"/>
-          </a:xfrm>
-          <a:prstGeom prst="rect">
-            <a:avLst/>
-          </a:prstGeom>
-          <a:noFill/>
-          <a:ln/>
-        </p:spPr>
-        <p:txBody>
-          <a:bodyPr wrap="square" anchor="t" lIns="25400" rIns="25400" tIns="25400" bIns="25400">
-            <a:spAutoFit/>
-          </a:bodyPr>
-          <a:lstStyle/>
-          <a:p>
-            <a:pPr algn="l">
-              <a:lnSpc>
-                <a:spcPct val="100000"/>
-              </a:lnSpc>
-              <a:spcBef>
-                <a:spcPts val="0"/>
-              </a:spcBef>
-              <a:spcAft>
-                <a:spcPts val="0"/>
-              </a:spcAft>
-            </a:pPr>
-            <a:r>
-              <a:rPr sz="830" b="1" i="0">
-                <a:solidFill>
-                  <a:srgbClr val="64748B"/>
-                </a:solidFill>
-                <a:latin typeface="Calibri"/>
-              </a:rPr>
-              <a:t>Jose Manuel Callecusi Guarachi</a:t>
-            </a:r>
-          </a:p>
-        </p:txBody>
-      </p:sp>
-      <p:sp>
-        <p:nvSpPr>
-          <p:cNvPr id="18" name="TextBox 17"/>
-          <p:cNvSpPr txBox="1"/>
-          <p:nvPr/>
-        </p:nvSpPr>
-        <p:spPr>
-          <a:xfrm>
-            <a:off x="3703320" y="5093208"/>
-            <a:ext cx="2286000" cy="164592"/>
-          </a:xfrm>
-          <a:prstGeom prst="rect">
-            <a:avLst/>
-          </a:prstGeom>
-          <a:noFill/>
-          <a:ln/>
-        </p:spPr>
-        <p:txBody>
-          <a:bodyPr wrap="square" anchor="t" lIns="25400" rIns="25400" tIns="25400" bIns="25400">
-            <a:spAutoFit/>
-          </a:bodyPr>
-          <a:lstStyle/>
-          <a:p>
-            <a:pPr algn="l">
-              <a:lnSpc>
-                <a:spcPct val="100000"/>
-              </a:lnSpc>
-              <a:spcBef>
-                <a:spcPts val="0"/>
-              </a:spcBef>
-              <a:spcAft>
-                <a:spcPts val="0"/>
-              </a:spcAft>
-            </a:pPr>
-            <a:r>
-              <a:rPr sz="830" b="1" i="0">
+              <a:rPr sz="1400" b="0" i="0">
                 <a:solidFill>
                   <a:srgbClr val="64748B"/>
                 </a:solidFill>
@@ -11998,8 +11898,8 @@
         </p:nvSpPr>
         <p:spPr>
           <a:xfrm>
-            <a:off x="3703320" y="5742432"/>
-            <a:ext cx="4754880" cy="237744"/>
+            <a:off x="594360" y="5650992"/>
+            <a:ext cx="7955279" cy="566928"/>
           </a:xfrm>
           <a:prstGeom prst="rect">
             <a:avLst/>
@@ -12008,141 +11908,26 @@
           <a:ln/>
         </p:spPr>
         <p:txBody>
-          <a:bodyPr wrap="square" anchor="t" lIns="25400" rIns="25400" tIns="25400" bIns="25400">
+          <a:bodyPr wrap="square" anchor="ctr" lIns="18288" rIns="18288" tIns="9144" bIns="9144">
             <a:spAutoFit/>
           </a:bodyPr>
           <a:lstStyle/>
           <a:p>
-            <a:pPr algn="l">
-              <a:lnSpc>
-                <a:spcPct val="100000"/>
-              </a:lnSpc>
-              <a:spcBef>
-                <a:spcPts val="0"/>
-              </a:spcBef>
-              <a:spcAft>
-                <a:spcPts val="0"/>
-              </a:spcAft>
-            </a:pPr>
+            <a:pPr algn="ctr"/>
             <a:r>
-              <a:rPr sz="919" b="0" i="0">
+              <a:rPr sz="2500" b="1">
                 <a:solidFill>
-                  <a:srgbClr val="64748B"/>
+                  <a:srgbClr val="18488B"/>
                 </a:solidFill>
-                <a:latin typeface="Calibri"/>
               </a:rPr>
-              <a:t>Universidad Privada Domingo Savio</a:t>
+              <a:t>UNIVERSIDAD PRIVADA DOMINGO SAVIO</a:t>
             </a:r>
-          </a:p>
-        </p:txBody>
-      </p:sp>
-      <p:sp>
-        <p:nvSpPr>
-          <p:cNvPr id="22" name="Rounded Rectangle 21"/>
-          <p:cNvSpPr/>
-          <p:nvPr/>
-        </p:nvSpPr>
-        <p:spPr>
-          <a:gradFill rotWithShape="1">
-            <a:gsLst>
-              <a:gs pos="0">
-                <a:srgbClr val="16B9B0"/>
-              </a:gs>
-              <a:gs pos="42000">
-                <a:srgbClr val="F5C66A"/>
-              </a:gs>
-              <a:gs pos="72000">
-                <a:srgbClr val="6D7BF7"/>
-              </a:gs>
-              <a:gs pos="100000">
-                <a:srgbClr val="16B9B0"/>
-              </a:gs>
-            </a:gsLst>
-            <a:lin ang="2700000" scaled="1"/>
-          </a:gradFill>
-          <a:xfrm>
-            <a:off x="5230368" y="2084831"/>
-            <a:ext cx="1828800" cy="1426464"/>
-          </a:xfrm>
-          <a:prstGeom prst="roundRect">
-            <a:avLst/>
-          </a:prstGeom>
-          <a:ln w="13970">
-            <a:solidFill>
-              <a:srgbClr val="FFFFFF"/>
-            </a:solidFill>
-          </a:ln>
-        </p:spPr>
-        <p:style>
-          <a:lnRef idx="1">
-            <a:schemeClr val="accent1"/>
-          </a:lnRef>
-          <a:fillRef idx="3">
-            <a:schemeClr val="accent1"/>
-          </a:fillRef>
-          <a:effectRef idx="2">
-            <a:schemeClr val="accent1"/>
-          </a:effectRef>
-          <a:fontRef idx="minor">
-            <a:schemeClr val="lt1"/>
-          </a:fontRef>
-        </p:style>
-        <p:txBody>
-          <a:bodyPr rtlCol="0" anchor="ctr"/>
-          <a:lstStyle/>
-          <a:p>
-            <a:pPr algn="ctr"/>
-          </a:p>
-        </p:txBody>
-      </p:sp>
-      <p:sp>
-        <p:nvSpPr>
-          <p:cNvPr id="23" name="Rounded Rectangle 22"/>
-          <p:cNvSpPr/>
-          <p:nvPr/>
-        </p:nvSpPr>
-        <p:spPr>
-          <a:xfrm>
-            <a:off x="5253228" y="2107692"/>
-            <a:ext cx="1783080" cy="1380744"/>
-          </a:xfrm>
-          <a:prstGeom prst="roundRect">
-            <a:avLst/>
-          </a:prstGeom>
-          <a:solidFill>
-            <a:srgbClr val="F8FAFC"/>
-          </a:solidFill>
-          <a:ln w="10160">
-            <a:solidFill>
-              <a:srgbClr val="FFFFFF"/>
-            </a:solidFill>
-          </a:ln>
-        </p:spPr>
-        <p:style>
-          <a:lnRef idx="1">
-            <a:schemeClr val="accent1"/>
-          </a:lnRef>
-          <a:fillRef idx="3">
-            <a:schemeClr val="accent1"/>
-          </a:fillRef>
-          <a:effectRef idx="2">
-            <a:schemeClr val="accent1"/>
-          </a:effectRef>
-          <a:fontRef idx="minor">
-            <a:schemeClr val="lt1"/>
-          </a:fontRef>
-        </p:style>
-        <p:txBody>
-          <a:bodyPr rtlCol="0" anchor="ctr"/>
-          <a:lstStyle/>
-          <a:p>
-            <a:pPr algn="ctr"/>
           </a:p>
         </p:txBody>
       </p:sp>
       <p:pic>
         <p:nvPicPr>
-          <p:cNvPr id="21" name="Picture 20" descr="foto-grupal.jpeg"/>
+          <p:cNvPr id="21" name="Foto grupal · orientación corregida" descr="image.jpg"/>
           <p:cNvPicPr>
             <a:picLocks noChangeAspect="1"/>
           </p:cNvPicPr>
@@ -12155,9 +11940,9 @@
           </a:stretch>
         </p:blipFill>
         <p:spPr>
-          <a:xfrm>
-            <a:off x="5340096" y="2139696"/>
-            <a:ext cx="1609344" cy="1207008"/>
+          <a:xfrm rot="16200000">
+            <a:off x="1108710" y="1680210"/>
+            <a:ext cx="3086100" cy="4114800"/>
           </a:xfrm>
           <a:prstGeom prst="rect">
             <a:avLst/>
@@ -18051,25 +17836,8 @@
           </a:bodyPr>
           <a:lstStyle/>
           <a:p>
-            <a:pPr algn="l">
-              <a:lnSpc>
-                <a:spcPct val="100000"/>
-              </a:lnSpc>
-              <a:spcBef>
-                <a:spcPts val="0"/>
-              </a:spcBef>
-              <a:spcAft>
-                <a:spcPts val="0"/>
-              </a:spcAft>
-            </a:pPr>
             <a:r>
-              <a:rPr sz="869" b="1" i="0">
-                <a:solidFill>
-                  <a:srgbClr val="0075A9"/>
-                </a:solidFill>
-                <a:latin typeface="Calibri"/>
-              </a:rPr>
-              <a:t>DIGITAL · LIBRO 1</a:t>
+              <a:t>DIGITAL · BIBLIOTECA UCB</a:t>
             </a:r>
           </a:p>
         </p:txBody>
@@ -18271,25 +18039,8 @@
           </a:bodyPr>
           <a:lstStyle/>
           <a:p>
-            <a:pPr algn="l">
-              <a:lnSpc>
-                <a:spcPct val="100000"/>
-              </a:lnSpc>
-              <a:spcBef>
-                <a:spcPts val="0"/>
-              </a:spcBef>
-              <a:spcAft>
-                <a:spcPts val="0"/>
-              </a:spcAft>
-            </a:pPr>
             <a:r>
-              <a:rPr sz="869" b="1" i="0">
-                <a:solidFill>
-                  <a:srgbClr val="0075A9"/>
-                </a:solidFill>
-                <a:latin typeface="Calibri"/>
-              </a:rPr>
-              <a:t>DIGITAL · LIBRO 2</a:t>
+              <a:t>DIGITAL · BIBLIOTECA UCB</a:t>
             </a:r>
           </a:p>
         </p:txBody>
@@ -18443,7 +18194,7 @@
         <p:spPr>
           <a:xfrm>
             <a:off x="566928" y="3950208"/>
-            <a:ext cx="8010144" cy="1261872"/>
+            <a:ext cx="8010144" cy="1645920"/>
           </a:xfrm>
           <a:prstGeom prst="roundRect">
             <a:avLst>
@@ -18491,25 +18242,8 @@
           </a:bodyPr>
           <a:lstStyle/>
           <a:p>
-            <a:pPr algn="l">
-              <a:lnSpc>
-                <a:spcPct val="100000"/>
-              </a:lnSpc>
-              <a:spcBef>
-                <a:spcPts val="0"/>
-              </a:spcBef>
-              <a:spcAft>
-                <a:spcPts val="0"/>
-              </a:spcAft>
-            </a:pPr>
             <a:r>
-              <a:rPr sz="869" b="1" i="0">
-                <a:solidFill>
-                  <a:srgbClr val="0075A9"/>
-                </a:solidFill>
-                <a:latin typeface="Calibri"/>
-              </a:rPr>
-              <a:t>IMPRESO · LIBRO 3</a:t>
+              <a:t>IMPRESO · EJEMPLAR CONSULTADO</a:t>
             </a:r>
           </a:p>
         </p:txBody>
@@ -18654,113 +18388,9 @@
           </a:p>
         </p:txBody>
       </p:sp>
-      <p:sp>
-        <p:nvSpPr>
-          <p:cNvPr id="22" name="Rounded Rectangle 21"/>
-          <p:cNvSpPr/>
-          <p:nvPr/>
-        </p:nvSpPr>
-        <p:spPr>
-          <a:gradFill rotWithShape="1">
-            <a:gsLst>
-              <a:gs pos="0">
-                <a:srgbClr val="16B9B0"/>
-              </a:gs>
-              <a:gs pos="42000">
-                <a:srgbClr val="F5C66A"/>
-              </a:gs>
-              <a:gs pos="72000">
-                <a:srgbClr val="6D7BF7"/>
-              </a:gs>
-              <a:gs pos="100000">
-                <a:srgbClr val="16B9B0"/>
-              </a:gs>
-            </a:gsLst>
-            <a:lin ang="2700000" scaled="1"/>
-          </a:gradFill>
-          <a:xfrm>
-            <a:off x="7370064" y="4005072"/>
-            <a:ext cx="877824" cy="1133856"/>
-          </a:xfrm>
-          <a:prstGeom prst="roundRect">
-            <a:avLst/>
-          </a:prstGeom>
-          <a:ln w="13970">
-            <a:solidFill>
-              <a:srgbClr val="FFFFFF"/>
-            </a:solidFill>
-          </a:ln>
-        </p:spPr>
-        <p:style>
-          <a:lnRef idx="1">
-            <a:schemeClr val="accent1"/>
-          </a:lnRef>
-          <a:fillRef idx="3">
-            <a:schemeClr val="accent1"/>
-          </a:fillRef>
-          <a:effectRef idx="2">
-            <a:schemeClr val="accent1"/>
-          </a:effectRef>
-          <a:fontRef idx="minor">
-            <a:schemeClr val="lt1"/>
-          </a:fontRef>
-        </p:style>
-        <p:txBody>
-          <a:bodyPr rtlCol="0" anchor="ctr"/>
-          <a:lstStyle/>
-          <a:p>
-            <a:pPr algn="ctr"/>
-          </a:p>
-        </p:txBody>
-      </p:sp>
-      <p:sp>
-        <p:nvSpPr>
-          <p:cNvPr id="23" name="Rounded Rectangle 22"/>
-          <p:cNvSpPr/>
-          <p:nvPr/>
-        </p:nvSpPr>
-        <p:spPr>
-          <a:xfrm>
-            <a:off x="7392924" y="4027932"/>
-            <a:ext cx="832103" cy="1088136"/>
-          </a:xfrm>
-          <a:prstGeom prst="roundRect">
-            <a:avLst/>
-          </a:prstGeom>
-          <a:solidFill>
-            <a:srgbClr val="F8FAFC"/>
-          </a:solidFill>
-          <a:ln w="10160">
-            <a:solidFill>
-              <a:srgbClr val="FFFFFF"/>
-            </a:solidFill>
-          </a:ln>
-        </p:spPr>
-        <p:style>
-          <a:lnRef idx="1">
-            <a:schemeClr val="accent1"/>
-          </a:lnRef>
-          <a:fillRef idx="3">
-            <a:schemeClr val="accent1"/>
-          </a:fillRef>
-          <a:effectRef idx="2">
-            <a:schemeClr val="accent1"/>
-          </a:effectRef>
-          <a:fontRef idx="minor">
-            <a:schemeClr val="lt1"/>
-          </a:fontRef>
-        </p:style>
-        <p:txBody>
-          <a:bodyPr rtlCol="0" anchor="ctr"/>
-          <a:lstStyle/>
-          <a:p>
-            <a:pPr algn="ctr"/>
-          </a:p>
-        </p:txBody>
-      </p:sp>
       <p:pic>
         <p:nvPicPr>
-          <p:cNvPr id="24" name="Picture 23" descr="Portada de UML con Rational Rose, de Gesvin Romero Moreno."/>
+          <p:cNvPr id="22" name="Foto del libro impreso · tema 01" descr="image.jpg"/>
           <p:cNvPicPr>
             <a:picLocks noChangeAspect="1"/>
           </p:cNvPicPr>
@@ -18774,8 +18404,8 @@
         </p:blipFill>
         <p:spPr>
           <a:xfrm>
-            <a:off x="7424927" y="4059936"/>
-            <a:ext cx="768096" cy="1024128"/>
+            <a:off x="7150608" y="4014215"/>
+            <a:ext cx="1097280" cy="1463040"/>
           </a:xfrm>
           <a:prstGeom prst="rect">
             <a:avLst/>

</xml_diff>

<commit_message>
Sincroniza herramientas UML y presentaciones
</commit_message>
<xml_diff>
--- a/materiales/actividad-1/tema-01-uml-requisitos-v23.pptx
+++ b/materiales/actividad-1/tema-01-uml-requisitos-v23.pptx
@@ -12,6 +12,7 @@
     <p:sldId id="260" r:id="rId4"/>
     <p:sldId id="261" r:id="rId3"/>
     <p:sldId id="262" r:id="rId2"/>
+    <p:sldId id="264" r:id="rId14"/>
     <p:sldId id="263" r:id="rId13"/>
   </p:sldIdLst>
   <p:sldSz cx="9144000" cy="6858000" type="screen4x3"/>
@@ -11525,8 +11526,8 @@
         </p:nvSpPr>
         <p:spPr>
           <a:xfrm>
-            <a:off x="594360" y="438912"/>
-            <a:ext cx="7955279" cy="237744"/>
+            <a:off x="2743200" y="438912"/>
+            <a:ext cx="5989320" cy="256032"/>
           </a:xfrm>
           <a:prstGeom prst="rect">
             <a:avLst/>
@@ -11542,7 +11543,11 @@
           <a:p>
             <a:pPr algn="l"/>
             <a:r>
-              <a:rPr sz="1300" b="1"/>
+              <a:rPr sz="1300" b="1">
+                <a:solidFill>
+                  <a:srgbClr val="22303C"/>
+                </a:solidFill>
+              </a:rPr>
               <a:t>ACTIVIDAD 1 · TEMA 01</a:t>
             </a:r>
           </a:p>
@@ -11556,8 +11561,8 @@
         </p:nvSpPr>
         <p:spPr>
           <a:xfrm>
-            <a:off x="594360" y="749808"/>
-            <a:ext cx="7955279" cy="658368"/>
+            <a:off x="2743200" y="768096"/>
+            <a:ext cx="5989320" cy="658368"/>
           </a:xfrm>
           <a:prstGeom prst="rect">
             <a:avLst/>
@@ -11585,7 +11590,7 @@
             <a:r>
               <a:rPr sz="2900" b="1" i="0">
                 <a:solidFill>
-                  <a:srgbClr val="1D4696"/>
+                  <a:srgbClr val="22303C"/>
                 </a:solidFill>
                 <a:latin typeface="Calibri Light"/>
               </a:rPr>
@@ -11602,8 +11607,8 @@
         </p:nvSpPr>
         <p:spPr>
           <a:xfrm>
-            <a:off x="594360" y="1481328"/>
-            <a:ext cx="7955279" cy="347472"/>
+            <a:off x="2743200" y="1490472"/>
+            <a:ext cx="5989320" cy="347472"/>
           </a:xfrm>
           <a:prstGeom prst="rect">
             <a:avLst/>
@@ -11621,7 +11626,7 @@
             <a:r>
               <a:rPr sz="1800" b="1">
                 <a:solidFill>
-                  <a:srgbClr val="18488B"/>
+                  <a:srgbClr val="22303C"/>
                 </a:solidFill>
               </a:rPr>
               <a:t>SISTEMAS DE INFORMACIÓN I</a:t>
@@ -11898,8 +11903,8 @@
         </p:nvSpPr>
         <p:spPr>
           <a:xfrm>
-            <a:off x="594360" y="5650992"/>
-            <a:ext cx="7955279" cy="566928"/>
+            <a:off x="2743200" y="5623560"/>
+            <a:ext cx="5989320" cy="566928"/>
           </a:xfrm>
           <a:prstGeom prst="rect">
             <a:avLst/>
@@ -11915,9 +11920,9 @@
           <a:p>
             <a:pPr algn="ctr"/>
             <a:r>
-              <a:rPr sz="2500" b="1">
-                <a:solidFill>
-                  <a:srgbClr val="18488B"/>
+              <a:rPr sz="2000" b="1">
+                <a:solidFill>
+                  <a:srgbClr val="22303C"/>
                 </a:solidFill>
               </a:rPr>
               <a:t>UNIVERSIDAD PRIVADA DOMINGO SAVIO</a:t>
@@ -11940,7 +11945,7 @@
           </a:stretch>
         </p:blipFill>
         <p:spPr>
-          <a:xfrm rot="16200000">
+          <a:xfrm rot="5400000">
             <a:off x="1108710" y="1680210"/>
             <a:ext cx="3086100" cy="4114800"/>
           </a:xfrm>
@@ -13002,34 +13007,8 @@
           </a:bodyPr>
           <a:lstStyle/>
           <a:p>
-            <a:pPr algn="l">
-              <a:lnSpc>
-                <a:spcPct val="100000"/>
-              </a:lnSpc>
-              <a:spcBef>
-                <a:spcPts val="0"/>
-              </a:spcBef>
-              <a:spcAft>
-                <a:spcPts val="0"/>
-              </a:spcAft>
-            </a:pPr>
             <a:r>
-              <a:rPr sz="760" b="1" i="0">
-                <a:solidFill>
-                  <a:srgbClr val="64748B"/>
-                </a:solidFill>
-                <a:latin typeface="Calibri"/>
-              </a:rPr>
-              <a:t>Fuente: </a:t>
-            </a:r>
-            <a:r>
-              <a:rPr sz="760" b="0" i="0">
-                <a:solidFill>
-                  <a:srgbClr val="64748B"/>
-                </a:solidFill>
-                <a:latin typeface="Calibri"/>
-              </a:rPr>
-              <a:t>NASA Systems Engineering Handbook · Investigación de la materia  ·  as of 6 de octubre de 2026</a:t>
+              <a:t>Fuente: necesidades y actores del análisis del sistema · investigación de la materia</a:t>
             </a:r>
           </a:p>
         </p:txBody>
@@ -13896,34 +13875,8 @@
           </a:bodyPr>
           <a:lstStyle/>
           <a:p>
-            <a:pPr algn="l">
-              <a:lnSpc>
-                <a:spcPct val="100000"/>
-              </a:lnSpc>
-              <a:spcBef>
-                <a:spcPts val="0"/>
-              </a:spcBef>
-              <a:spcAft>
-                <a:spcPts val="0"/>
-              </a:spcAft>
-            </a:pPr>
             <a:r>
-              <a:rPr sz="760" b="1" i="0">
-                <a:solidFill>
-                  <a:srgbClr val="64748B"/>
-                </a:solidFill>
-                <a:latin typeface="Calibri"/>
-              </a:rPr>
-              <a:t>Fuente: </a:t>
-            </a:r>
-            <a:r>
-              <a:rPr sz="760" b="0" i="0">
-                <a:solidFill>
-                  <a:srgbClr val="64748B"/>
-                </a:solidFill>
-                <a:latin typeface="Calibri"/>
-              </a:rPr>
-              <a:t>OMG, UML 2.5.1 · NASA, guía de requisitos  ·  as of 6 de octubre de 2026</a:t>
+              <a:t>Fuentes: OMG, UML 2.5.1 · requisitos y trazabilidad del caso bibliotecario</a:t>
             </a:r>
           </a:p>
         </p:txBody>
@@ -14565,34 +14518,8 @@
           </a:bodyPr>
           <a:lstStyle/>
           <a:p>
-            <a:pPr algn="l">
-              <a:lnSpc>
-                <a:spcPct val="100000"/>
-              </a:lnSpc>
-              <a:spcBef>
-                <a:spcPts val="0"/>
-              </a:spcBef>
-              <a:spcAft>
-                <a:spcPts val="0"/>
-              </a:spcAft>
-            </a:pPr>
             <a:r>
-              <a:rPr sz="760" b="1" i="0">
-                <a:solidFill>
-                  <a:srgbClr val="64748B"/>
-                </a:solidFill>
-                <a:latin typeface="Calibri"/>
-              </a:rPr>
-              <a:t>Fuente: </a:t>
-            </a:r>
-            <a:r>
-              <a:rPr sz="760" b="0" i="0">
-                <a:solidFill>
-                  <a:srgbClr val="64748B"/>
-                </a:solidFill>
-                <a:latin typeface="Calibri"/>
-              </a:rPr>
-              <a:t>NASA Systems Engineering Handbook · Ejemplo de análisis  ·  as of 6 de octubre de 2026</a:t>
+              <a:t>Fuentes: OMG, UML 2.5.1 · criterios de calidad del caso bibliotecario</a:t>
             </a:r>
           </a:p>
         </p:txBody>
@@ -17656,6 +17583,1167 @@
             <a:avLst/>
           </a:prstGeom>
           <a:noFill/>
+        </p:spPr>
+        <p:txBody>
+          <a:bodyPr wrap="square" anchor="ctr">
+            <a:spAutoFit/>
+          </a:bodyPr>
+          <a:lstStyle/>
+          <a:p>
+            <a:pPr algn="l"/>
+            <a:r>
+              <a:rPr sz="2300" b="1">
+                <a:solidFill>
+                  <a:srgbClr val="22303C"/>
+                </a:solidFill>
+                <a:latin typeface="Aptos"/>
+              </a:rPr>
+              <a:t>UML ofrece vistas distintas y herramientas para modelarlas</a:t>
+            </a:r>
+          </a:p>
+        </p:txBody>
+      </p:sp>
+      <p:sp>
+        <p:nvSpPr>
+          <p:cNvPr id="5" name="TextBox 4"/>
+          <p:cNvSpPr txBox="1"/>
+          <p:nvPr/>
+        </p:nvSpPr>
+        <p:spPr>
+          <a:xfrm>
+            <a:off x="621792" y="777240"/>
+            <a:ext cx="7863840" cy="274320"/>
+          </a:xfrm>
+          <a:prstGeom prst="rect">
+            <a:avLst/>
+          </a:prstGeom>
+          <a:noFill/>
+        </p:spPr>
+        <p:txBody>
+          <a:bodyPr wrap="square" anchor="ctr">
+            <a:spAutoFit/>
+          </a:bodyPr>
+          <a:lstStyle/>
+          <a:p>
+            <a:pPr algn="l"/>
+            <a:r>
+              <a:rPr sz="1000" b="1">
+                <a:solidFill>
+                  <a:srgbClr val="195E7F"/>
+                </a:solidFill>
+                <a:latin typeface="Aptos"/>
+              </a:rPr>
+              <a:t>CASO APLICADO · CATÁLOGO PÚBLICO UPDS · DIAGRAMA DE CASOS DE USO</a:t>
+            </a:r>
+          </a:p>
+        </p:txBody>
+      </p:sp>
+      <p:sp>
+        <p:nvSpPr>
+          <p:cNvPr id="6" name="TextBox 5"/>
+          <p:cNvSpPr txBox="1"/>
+          <p:nvPr/>
+        </p:nvSpPr>
+        <p:spPr>
+          <a:xfrm>
+            <a:off x="7882127" y="210312"/>
+            <a:ext cx="749808" cy="219456"/>
+          </a:xfrm>
+          <a:prstGeom prst="rect">
+            <a:avLst/>
+          </a:prstGeom>
+          <a:noFill/>
+        </p:spPr>
+        <p:txBody>
+          <a:bodyPr wrap="square" anchor="ctr">
+            <a:spAutoFit/>
+          </a:bodyPr>
+          <a:lstStyle/>
+          <a:p>
+            <a:pPr algn="r"/>
+            <a:r>
+              <a:rPr sz="900" b="1">
+                <a:solidFill>
+                  <a:srgbClr val="195E7F"/>
+                </a:solidFill>
+                <a:latin typeface="Aptos"/>
+              </a:rPr>
+              <a:t>06 · UML</a:t>
+            </a:r>
+          </a:p>
+        </p:txBody>
+      </p:sp>
+      <p:sp>
+        <p:nvSpPr>
+          <p:cNvPr id="7" name="Rectangle 6"/>
+          <p:cNvSpPr/>
+          <p:nvPr/>
+        </p:nvSpPr>
+        <p:spPr>
+          <a:xfrm>
+            <a:off x="1874519" y="1417320"/>
+            <a:ext cx="2880360" cy="2999232"/>
+          </a:xfrm>
+          <a:prstGeom prst="rect">
+            <a:avLst/>
+          </a:prstGeom>
+          <a:noFill/>
+          <a:ln w="22860">
+            <a:solidFill>
+              <a:srgbClr val="2D698C"/>
+            </a:solidFill>
+          </a:ln>
+        </p:spPr>
+        <p:style>
+          <a:lnRef idx="1">
+            <a:schemeClr val="accent1"/>
+          </a:lnRef>
+          <a:fillRef idx="3">
+            <a:schemeClr val="accent1"/>
+          </a:fillRef>
+          <a:effectRef idx="2">
+            <a:schemeClr val="accent1"/>
+          </a:effectRef>
+          <a:fontRef idx="minor">
+            <a:schemeClr val="lt1"/>
+          </a:fontRef>
+        </p:style>
+        <p:txBody>
+          <a:bodyPr rtlCol="0" anchor="t"/>
+          <a:lstStyle/>
+          <a:p>
+            <a:pPr algn="ctr"/>
+            <a:r>
+              <a:rPr sz="1200" b="1">
+                <a:solidFill>
+                  <a:srgbClr val="195E7F"/>
+                </a:solidFill>
+                <a:latin typeface="Aptos"/>
+              </a:rPr>
+              <a:t>Catálogo bibliotecario</a:t>
+            </a:r>
+          </a:p>
+        </p:txBody>
+      </p:sp>
+      <p:sp>
+        <p:nvSpPr>
+          <p:cNvPr id="8" name="Oval 7"/>
+          <p:cNvSpPr/>
+          <p:nvPr/>
+        </p:nvSpPr>
+        <p:spPr>
+          <a:xfrm>
+            <a:off x="2468880" y="1755648"/>
+            <a:ext cx="1737360" cy="566928"/>
+          </a:xfrm>
+          <a:prstGeom prst="ellipse">
+            <a:avLst/>
+          </a:prstGeom>
+          <a:solidFill>
+            <a:srgbClr val="E7F4F9"/>
+          </a:solidFill>
+          <a:ln w="17780">
+            <a:solidFill>
+              <a:srgbClr val="2D698C"/>
+            </a:solidFill>
+          </a:ln>
+        </p:spPr>
+        <p:style>
+          <a:lnRef idx="1">
+            <a:schemeClr val="accent1"/>
+          </a:lnRef>
+          <a:fillRef idx="3">
+            <a:schemeClr val="accent1"/>
+          </a:fillRef>
+          <a:effectRef idx="2">
+            <a:schemeClr val="accent1"/>
+          </a:effectRef>
+          <a:fontRef idx="minor">
+            <a:schemeClr val="lt1"/>
+          </a:fontRef>
+        </p:style>
+        <p:txBody>
+          <a:bodyPr rtlCol="0" anchor="ctr"/>
+          <a:lstStyle/>
+          <a:p>
+            <a:pPr algn="ctr"/>
+            <a:r>
+              <a:rPr sz="1100">
+                <a:solidFill>
+                  <a:srgbClr val="22303C"/>
+                </a:solidFill>
+                <a:latin typeface="Aptos"/>
+              </a:rPr>
+              <a:t>Buscar título</a:t>
+            </a:r>
+          </a:p>
+        </p:txBody>
+      </p:sp>
+      <p:sp>
+        <p:nvSpPr>
+          <p:cNvPr id="9" name="Oval 8"/>
+          <p:cNvSpPr/>
+          <p:nvPr/>
+        </p:nvSpPr>
+        <p:spPr>
+          <a:xfrm>
+            <a:off x="2468880" y="2578608"/>
+            <a:ext cx="1737360" cy="566928"/>
+          </a:xfrm>
+          <a:prstGeom prst="ellipse">
+            <a:avLst/>
+          </a:prstGeom>
+          <a:solidFill>
+            <a:srgbClr val="E7F4F9"/>
+          </a:solidFill>
+          <a:ln w="17780">
+            <a:solidFill>
+              <a:srgbClr val="2D698C"/>
+            </a:solidFill>
+          </a:ln>
+        </p:spPr>
+        <p:style>
+          <a:lnRef idx="1">
+            <a:schemeClr val="accent1"/>
+          </a:lnRef>
+          <a:fillRef idx="3">
+            <a:schemeClr val="accent1"/>
+          </a:fillRef>
+          <a:effectRef idx="2">
+            <a:schemeClr val="accent1"/>
+          </a:effectRef>
+          <a:fontRef idx="minor">
+            <a:schemeClr val="lt1"/>
+          </a:fontRef>
+        </p:style>
+        <p:txBody>
+          <a:bodyPr rtlCol="0" anchor="ctr"/>
+          <a:lstStyle/>
+          <a:p>
+            <a:pPr algn="ctr"/>
+            <a:r>
+              <a:rPr sz="1100">
+                <a:solidFill>
+                  <a:srgbClr val="22303C"/>
+                </a:solidFill>
+                <a:latin typeface="Aptos"/>
+              </a:rPr>
+              <a:t>Consultar ficha</a:t>
+            </a:r>
+          </a:p>
+        </p:txBody>
+      </p:sp>
+      <p:sp>
+        <p:nvSpPr>
+          <p:cNvPr id="10" name="Oval 9"/>
+          <p:cNvSpPr/>
+          <p:nvPr/>
+        </p:nvSpPr>
+        <p:spPr>
+          <a:xfrm>
+            <a:off x="2468880" y="3401568"/>
+            <a:ext cx="1737360" cy="566928"/>
+          </a:xfrm>
+          <a:prstGeom prst="ellipse">
+            <a:avLst/>
+          </a:prstGeom>
+          <a:solidFill>
+            <a:srgbClr val="E7F4F9"/>
+          </a:solidFill>
+          <a:ln w="17780">
+            <a:solidFill>
+              <a:srgbClr val="2D698C"/>
+            </a:solidFill>
+          </a:ln>
+        </p:spPr>
+        <p:style>
+          <a:lnRef idx="1">
+            <a:schemeClr val="accent1"/>
+          </a:lnRef>
+          <a:fillRef idx="3">
+            <a:schemeClr val="accent1"/>
+          </a:fillRef>
+          <a:effectRef idx="2">
+            <a:schemeClr val="accent1"/>
+          </a:effectRef>
+          <a:fontRef idx="minor">
+            <a:schemeClr val="lt1"/>
+          </a:fontRef>
+        </p:style>
+        <p:txBody>
+          <a:bodyPr rtlCol="0" anchor="ctr"/>
+          <a:lstStyle/>
+          <a:p>
+            <a:pPr algn="ctr"/>
+            <a:r>
+              <a:rPr sz="1100">
+                <a:solidFill>
+                  <a:srgbClr val="22303C"/>
+                </a:solidFill>
+                <a:latin typeface="Aptos"/>
+              </a:rPr>
+              <a:t>Ver disponibilidad</a:t>
+            </a:r>
+          </a:p>
+        </p:txBody>
+      </p:sp>
+      <p:sp>
+        <p:nvSpPr>
+          <p:cNvPr id="11" name="Oval 10"/>
+          <p:cNvSpPr/>
+          <p:nvPr/>
+        </p:nvSpPr>
+        <p:spPr>
+          <a:xfrm>
+            <a:off x="868680" y="2148840"/>
+            <a:ext cx="310896" cy="310896"/>
+          </a:xfrm>
+          <a:prstGeom prst="ellipse">
+            <a:avLst/>
+          </a:prstGeom>
+          <a:noFill/>
+          <a:ln w="17780">
+            <a:solidFill>
+              <a:srgbClr val="22303C"/>
+            </a:solidFill>
+          </a:ln>
+        </p:spPr>
+        <p:style>
+          <a:lnRef idx="1">
+            <a:schemeClr val="accent1"/>
+          </a:lnRef>
+          <a:fillRef idx="3">
+            <a:schemeClr val="accent1"/>
+          </a:fillRef>
+          <a:effectRef idx="2">
+            <a:schemeClr val="accent1"/>
+          </a:effectRef>
+          <a:fontRef idx="minor">
+            <a:schemeClr val="lt1"/>
+          </a:fontRef>
+        </p:style>
+        <p:txBody>
+          <a:bodyPr rtlCol="0" anchor="ctr"/>
+          <a:lstStyle/>
+          <a:p>
+            <a:pPr algn="ctr"/>
+          </a:p>
+        </p:txBody>
+      </p:sp>
+      <p:cxnSp>
+        <p:nvCxnSpPr>
+          <p:cNvPr id="12" name="Connector 11"/>
+          <p:cNvCxnSpPr/>
+          <p:nvPr/>
+        </p:nvCxnSpPr>
+        <p:spPr>
+          <a:xfrm>
+            <a:off x="1024127" y="2459736"/>
+            <a:ext cx="1" cy="539496"/>
+          </a:xfrm>
+          <a:prstGeom prst="line">
+            <a:avLst/>
+          </a:prstGeom>
+          <a:ln w="17780">
+            <a:solidFill>
+              <a:srgbClr val="22303C"/>
+            </a:solidFill>
+          </a:ln>
+        </p:spPr>
+        <p:style>
+          <a:lnRef idx="2">
+            <a:schemeClr val="accent1"/>
+          </a:lnRef>
+          <a:fillRef idx="0">
+            <a:schemeClr val="accent1"/>
+          </a:fillRef>
+          <a:effectRef idx="1">
+            <a:schemeClr val="accent1"/>
+          </a:effectRef>
+          <a:fontRef idx="minor">
+            <a:schemeClr val="tx1"/>
+          </a:fontRef>
+        </p:style>
+      </p:cxnSp>
+      <p:cxnSp>
+        <p:nvCxnSpPr>
+          <p:cNvPr id="13" name="Connector 12"/>
+          <p:cNvCxnSpPr/>
+          <p:nvPr/>
+        </p:nvCxnSpPr>
+        <p:spPr>
+          <a:xfrm flipH="1">
+            <a:off x="749808" y="2651760"/>
+            <a:ext cx="274320" cy="164592"/>
+          </a:xfrm>
+          <a:prstGeom prst="line">
+            <a:avLst/>
+          </a:prstGeom>
+          <a:ln w="17780">
+            <a:solidFill>
+              <a:srgbClr val="22303C"/>
+            </a:solidFill>
+          </a:ln>
+        </p:spPr>
+        <p:style>
+          <a:lnRef idx="2">
+            <a:schemeClr val="accent1"/>
+          </a:lnRef>
+          <a:fillRef idx="0">
+            <a:schemeClr val="accent1"/>
+          </a:fillRef>
+          <a:effectRef idx="1">
+            <a:schemeClr val="accent1"/>
+          </a:effectRef>
+          <a:fontRef idx="minor">
+            <a:schemeClr val="tx1"/>
+          </a:fontRef>
+        </p:style>
+      </p:cxnSp>
+      <p:cxnSp>
+        <p:nvCxnSpPr>
+          <p:cNvPr id="14" name="Connector 13"/>
+          <p:cNvCxnSpPr/>
+          <p:nvPr/>
+        </p:nvCxnSpPr>
+        <p:spPr>
+          <a:xfrm>
+            <a:off x="1024128" y="2651760"/>
+            <a:ext cx="274320" cy="164592"/>
+          </a:xfrm>
+          <a:prstGeom prst="line">
+            <a:avLst/>
+          </a:prstGeom>
+          <a:ln w="17780">
+            <a:solidFill>
+              <a:srgbClr val="22303C"/>
+            </a:solidFill>
+          </a:ln>
+        </p:spPr>
+        <p:style>
+          <a:lnRef idx="2">
+            <a:schemeClr val="accent1"/>
+          </a:lnRef>
+          <a:fillRef idx="0">
+            <a:schemeClr val="accent1"/>
+          </a:fillRef>
+          <a:effectRef idx="1">
+            <a:schemeClr val="accent1"/>
+          </a:effectRef>
+          <a:fontRef idx="minor">
+            <a:schemeClr val="tx1"/>
+          </a:fontRef>
+        </p:style>
+      </p:cxnSp>
+      <p:cxnSp>
+        <p:nvCxnSpPr>
+          <p:cNvPr id="15" name="Connector 14"/>
+          <p:cNvCxnSpPr/>
+          <p:nvPr/>
+        </p:nvCxnSpPr>
+        <p:spPr>
+          <a:xfrm flipH="1">
+            <a:off x="822960" y="2999232"/>
+            <a:ext cx="201168" cy="310896"/>
+          </a:xfrm>
+          <a:prstGeom prst="line">
+            <a:avLst/>
+          </a:prstGeom>
+          <a:ln w="17780">
+            <a:solidFill>
+              <a:srgbClr val="22303C"/>
+            </a:solidFill>
+          </a:ln>
+        </p:spPr>
+        <p:style>
+          <a:lnRef idx="2">
+            <a:schemeClr val="accent1"/>
+          </a:lnRef>
+          <a:fillRef idx="0">
+            <a:schemeClr val="accent1"/>
+          </a:fillRef>
+          <a:effectRef idx="1">
+            <a:schemeClr val="accent1"/>
+          </a:effectRef>
+          <a:fontRef idx="minor">
+            <a:schemeClr val="tx1"/>
+          </a:fontRef>
+        </p:style>
+      </p:cxnSp>
+      <p:cxnSp>
+        <p:nvCxnSpPr>
+          <p:cNvPr id="16" name="Connector 15"/>
+          <p:cNvCxnSpPr/>
+          <p:nvPr/>
+        </p:nvCxnSpPr>
+        <p:spPr>
+          <a:xfrm>
+            <a:off x="1024128" y="2999232"/>
+            <a:ext cx="201168" cy="310896"/>
+          </a:xfrm>
+          <a:prstGeom prst="line">
+            <a:avLst/>
+          </a:prstGeom>
+          <a:ln w="17780">
+            <a:solidFill>
+              <a:srgbClr val="22303C"/>
+            </a:solidFill>
+          </a:ln>
+        </p:spPr>
+        <p:style>
+          <a:lnRef idx="2">
+            <a:schemeClr val="accent1"/>
+          </a:lnRef>
+          <a:fillRef idx="0">
+            <a:schemeClr val="accent1"/>
+          </a:fillRef>
+          <a:effectRef idx="1">
+            <a:schemeClr val="accent1"/>
+          </a:effectRef>
+          <a:fontRef idx="minor">
+            <a:schemeClr val="tx1"/>
+          </a:fontRef>
+        </p:style>
+      </p:cxnSp>
+      <p:sp>
+        <p:nvSpPr>
+          <p:cNvPr id="17" name="TextBox 16"/>
+          <p:cNvSpPr txBox="1"/>
+          <p:nvPr/>
+        </p:nvSpPr>
+        <p:spPr>
+          <a:xfrm>
+            <a:off x="621792" y="3364992"/>
+            <a:ext cx="822960" cy="320040"/>
+          </a:xfrm>
+          <a:prstGeom prst="rect">
+            <a:avLst/>
+          </a:prstGeom>
+          <a:noFill/>
+        </p:spPr>
+        <p:txBody>
+          <a:bodyPr wrap="square" anchor="ctr">
+            <a:spAutoFit/>
+          </a:bodyPr>
+          <a:lstStyle/>
+          <a:p>
+            <a:pPr algn="ctr"/>
+            <a:r>
+              <a:rPr sz="1000" b="1">
+                <a:solidFill>
+                  <a:srgbClr val="22303C"/>
+                </a:solidFill>
+                <a:latin typeface="Aptos"/>
+              </a:rPr>
+              <a:t>Estudiante</a:t>
+            </a:r>
+          </a:p>
+        </p:txBody>
+      </p:sp>
+      <p:cxnSp>
+        <p:nvCxnSpPr>
+          <p:cNvPr id="18" name="Connector 17"/>
+          <p:cNvCxnSpPr/>
+          <p:nvPr/>
+        </p:nvCxnSpPr>
+        <p:spPr>
+          <a:xfrm flipV="1">
+            <a:off x="1307592" y="2039112"/>
+            <a:ext cx="1161288" cy="758952"/>
+          </a:xfrm>
+          <a:prstGeom prst="line">
+            <a:avLst/>
+          </a:prstGeom>
+          <a:ln w="13970">
+            <a:solidFill>
+              <a:srgbClr val="5A6F7E"/>
+            </a:solidFill>
+          </a:ln>
+        </p:spPr>
+        <p:style>
+          <a:lnRef idx="2">
+            <a:schemeClr val="accent1"/>
+          </a:lnRef>
+          <a:fillRef idx="0">
+            <a:schemeClr val="accent1"/>
+          </a:fillRef>
+          <a:effectRef idx="1">
+            <a:schemeClr val="accent1"/>
+          </a:effectRef>
+          <a:fontRef idx="minor">
+            <a:schemeClr val="tx1"/>
+          </a:fontRef>
+        </p:style>
+      </p:cxnSp>
+      <p:cxnSp>
+        <p:nvCxnSpPr>
+          <p:cNvPr id="19" name="Connector 18"/>
+          <p:cNvCxnSpPr/>
+          <p:nvPr/>
+        </p:nvCxnSpPr>
+        <p:spPr>
+          <a:xfrm>
+            <a:off x="1307592" y="2798064"/>
+            <a:ext cx="1161288" cy="64008"/>
+          </a:xfrm>
+          <a:prstGeom prst="line">
+            <a:avLst/>
+          </a:prstGeom>
+          <a:ln w="13970">
+            <a:solidFill>
+              <a:srgbClr val="5A6F7E"/>
+            </a:solidFill>
+          </a:ln>
+        </p:spPr>
+        <p:style>
+          <a:lnRef idx="2">
+            <a:schemeClr val="accent1"/>
+          </a:lnRef>
+          <a:fillRef idx="0">
+            <a:schemeClr val="accent1"/>
+          </a:fillRef>
+          <a:effectRef idx="1">
+            <a:schemeClr val="accent1"/>
+          </a:effectRef>
+          <a:fontRef idx="minor">
+            <a:schemeClr val="tx1"/>
+          </a:fontRef>
+        </p:style>
+      </p:cxnSp>
+      <p:cxnSp>
+        <p:nvCxnSpPr>
+          <p:cNvPr id="20" name="Connector 19"/>
+          <p:cNvCxnSpPr/>
+          <p:nvPr/>
+        </p:nvCxnSpPr>
+        <p:spPr>
+          <a:xfrm>
+            <a:off x="1307592" y="2798064"/>
+            <a:ext cx="1161288" cy="886968"/>
+          </a:xfrm>
+          <a:prstGeom prst="line">
+            <a:avLst/>
+          </a:prstGeom>
+          <a:ln w="13970">
+            <a:solidFill>
+              <a:srgbClr val="5A6F7E"/>
+            </a:solidFill>
+          </a:ln>
+        </p:spPr>
+        <p:style>
+          <a:lnRef idx="2">
+            <a:schemeClr val="accent1"/>
+          </a:lnRef>
+          <a:fillRef idx="0">
+            <a:schemeClr val="accent1"/>
+          </a:fillRef>
+          <a:effectRef idx="1">
+            <a:schemeClr val="accent1"/>
+          </a:effectRef>
+          <a:fontRef idx="minor">
+            <a:schemeClr val="tx1"/>
+          </a:fontRef>
+        </p:style>
+      </p:cxnSp>
+      <p:sp>
+        <p:nvSpPr>
+          <p:cNvPr id="21" name="TextBox 20"/>
+          <p:cNvSpPr txBox="1"/>
+          <p:nvPr/>
+        </p:nvSpPr>
+        <p:spPr>
+          <a:xfrm>
+            <a:off x="5074920" y="1417320"/>
+            <a:ext cx="3520440" cy="2999232"/>
+          </a:xfrm>
+          <a:prstGeom prst="rect">
+            <a:avLst/>
+          </a:prstGeom>
+          <a:noFill/>
+        </p:spPr>
+        <p:txBody>
+          <a:bodyPr wrap="square">
+            <a:spAutoFit/>
+          </a:bodyPr>
+          <a:lstStyle/>
+          <a:p>
+            <a:pPr>
+              <a:spcAft>
+                <a:spcPts val="700"/>
+              </a:spcAft>
+            </a:pPr>
+            <a:r>
+              <a:rPr sz="1200" b="1">
+                <a:solidFill>
+                  <a:srgbClr val="195E7F"/>
+                </a:solidFill>
+                <a:latin typeface="Aptos"/>
+              </a:rPr>
+              <a:t>Modelos UML · qué permiten observar</a:t>
+            </a:r>
+          </a:p>
+          <a:p>
+            <a:pPr>
+              <a:spcAft>
+                <a:spcPts val="700"/>
+              </a:spcAft>
+            </a:pPr>
+            <a:r>
+              <a:rPr sz="1000" b="0">
+                <a:solidFill>
+                  <a:srgbClr val="22303C"/>
+                </a:solidFill>
+                <a:latin typeface="Aptos"/>
+              </a:rPr>
+              <a:t>Casos de uso: objetivos de los actores.</a:t>
+            </a:r>
+          </a:p>
+          <a:p>
+            <a:pPr>
+              <a:spcAft>
+                <a:spcPts val="700"/>
+              </a:spcAft>
+            </a:pPr>
+            <a:r>
+              <a:rPr sz="1000" b="0">
+                <a:solidFill>
+                  <a:srgbClr val="22303C"/>
+                </a:solidFill>
+                <a:latin typeface="Aptos"/>
+              </a:rPr>
+              <a:t>Actividad: pasos y decisiones del flujo.</a:t>
+            </a:r>
+          </a:p>
+          <a:p>
+            <a:pPr>
+              <a:spcAft>
+                <a:spcPts val="700"/>
+              </a:spcAft>
+            </a:pPr>
+            <a:r>
+              <a:rPr sz="1000" b="0">
+                <a:solidFill>
+                  <a:srgbClr val="22303C"/>
+                </a:solidFill>
+                <a:latin typeface="Aptos"/>
+              </a:rPr>
+              <a:t>Secuencia: mensajes ordenados en el tiempo.</a:t>
+            </a:r>
+          </a:p>
+          <a:p>
+            <a:pPr>
+              <a:spcAft>
+                <a:spcPts val="700"/>
+              </a:spcAft>
+            </a:pPr>
+            <a:r>
+              <a:rPr sz="1000" b="0">
+                <a:solidFill>
+                  <a:srgbClr val="22303C"/>
+                </a:solidFill>
+                <a:latin typeface="Aptos"/>
+              </a:rPr>
+              <a:t>Clases: estructura, atributos y asociaciones.</a:t>
+            </a:r>
+          </a:p>
+          <a:p>
+            <a:pPr>
+              <a:spcAft>
+                <a:spcPts val="700"/>
+              </a:spcAft>
+            </a:pPr>
+            <a:r>
+              <a:rPr sz="1000" b="0">
+                <a:solidFill>
+                  <a:srgbClr val="22303C"/>
+                </a:solidFill>
+                <a:latin typeface="Aptos"/>
+              </a:rPr>
+              <a:t>Estados: condiciones y transiciones de un objeto.</a:t>
+            </a:r>
+          </a:p>
+          <a:p>
+            <a:pPr>
+              <a:spcAft>
+                <a:spcPts val="700"/>
+              </a:spcAft>
+            </a:pPr>
+            <a:r>
+              <a:rPr sz="1000" b="0">
+                <a:solidFill>
+                  <a:srgbClr val="22303C"/>
+                </a:solidFill>
+                <a:latin typeface="Aptos"/>
+              </a:rPr>
+              <a:t>Componentes y despliegue: módulos y entorno de ejecución.</a:t>
+            </a:r>
+          </a:p>
+        </p:txBody>
+      </p:sp>
+      <p:sp>
+        <p:nvSpPr>
+          <p:cNvPr id="22" name="Rounded Rectangle 21">
+            <a:hlinkClick r:id="rId2"/>
+          </p:cNvPr>
+          <p:cNvSpPr/>
+          <p:nvPr/>
+        </p:nvSpPr>
+        <p:spPr>
+          <a:xfrm>
+            <a:off x="621792" y="4709160"/>
+            <a:ext cx="2487168" cy="713232"/>
+          </a:xfrm>
+          <a:prstGeom prst="roundRect">
+            <a:avLst/>
+          </a:prstGeom>
+          <a:solidFill>
+            <a:srgbClr val="ECF4F8"/>
+          </a:solidFill>
+          <a:ln>
+            <a:solidFill>
+              <a:srgbClr val="B4CDDB"/>
+            </a:solidFill>
+          </a:ln>
+        </p:spPr>
+        <p:style>
+          <a:lnRef idx="1">
+            <a:schemeClr val="accent1"/>
+          </a:lnRef>
+          <a:fillRef idx="3">
+            <a:schemeClr val="accent1"/>
+          </a:fillRef>
+          <a:effectRef idx="2">
+            <a:schemeClr val="accent1"/>
+          </a:effectRef>
+          <a:fontRef idx="minor">
+            <a:schemeClr val="lt1"/>
+          </a:fontRef>
+        </p:style>
+        <p:txBody>
+          <a:bodyPr rtlCol="0" anchor="ctr"/>
+          <a:lstStyle/>
+          <a:p>
+            <a:pPr algn="ctr"/>
+            <a:r>
+              <a:rPr sz="800" b="0">
+                <a:solidFill>
+                  <a:srgbClr val="195E7F"/>
+                </a:solidFill>
+                <a:latin typeface="Aptos"/>
+              </a:rPr>
+              <a:t>PlantUML</a:t>
+            </a:r>
+          </a:p>
+          <a:p>
+            <a:pPr algn="ctr"/>
+            <a:r>
+              <a:rPr sz="800" b="0">
+                <a:solidFill>
+                  <a:srgbClr val="195E7F"/>
+                </a:solidFill>
+                <a:latin typeface="Aptos"/>
+              </a:rPr>
+              <a:t>Editar este caso de uso</a:t>
+            </a:r>
+          </a:p>
+        </p:txBody>
+      </p:sp>
+      <p:sp>
+        <p:nvSpPr>
+          <p:cNvPr id="23" name="Rounded Rectangle 22">
+            <a:hlinkClick r:id="rId3"/>
+          </p:cNvPr>
+          <p:cNvSpPr/>
+          <p:nvPr/>
+        </p:nvSpPr>
+        <p:spPr>
+          <a:xfrm>
+            <a:off x="3291840" y="4709160"/>
+            <a:ext cx="2487168" cy="713232"/>
+          </a:xfrm>
+          <a:prstGeom prst="roundRect">
+            <a:avLst/>
+          </a:prstGeom>
+          <a:solidFill>
+            <a:srgbClr val="ECF4F8"/>
+          </a:solidFill>
+          <a:ln>
+            <a:solidFill>
+              <a:srgbClr val="B4CDDB"/>
+            </a:solidFill>
+          </a:ln>
+        </p:spPr>
+        <p:style>
+          <a:lnRef idx="1">
+            <a:schemeClr val="accent1"/>
+          </a:lnRef>
+          <a:fillRef idx="3">
+            <a:schemeClr val="accent1"/>
+          </a:fillRef>
+          <a:effectRef idx="2">
+            <a:schemeClr val="accent1"/>
+          </a:effectRef>
+          <a:fontRef idx="minor">
+            <a:schemeClr val="lt1"/>
+          </a:fontRef>
+        </p:style>
+        <p:txBody>
+          <a:bodyPr rtlCol="0" anchor="ctr"/>
+          <a:lstStyle/>
+          <a:p>
+            <a:pPr algn="ctr"/>
+            <a:r>
+              <a:rPr sz="800" b="0">
+                <a:solidFill>
+                  <a:srgbClr val="195E7F"/>
+                </a:solidFill>
+                <a:latin typeface="Aptos"/>
+              </a:rPr>
+              <a:t>diagrams.net</a:t>
+            </a:r>
+          </a:p>
+          <a:p>
+            <a:pPr algn="ctr"/>
+            <a:r>
+              <a:rPr sz="800" b="0">
+                <a:solidFill>
+                  <a:srgbClr val="195E7F"/>
+                </a:solidFill>
+                <a:latin typeface="Aptos"/>
+              </a:rPr>
+              <a:t>Modelado visual UML</a:t>
+            </a:r>
+          </a:p>
+        </p:txBody>
+      </p:sp>
+      <p:sp>
+        <p:nvSpPr>
+          <p:cNvPr id="24" name="Rounded Rectangle 23">
+            <a:hlinkClick r:id="rId4"/>
+          </p:cNvPr>
+          <p:cNvSpPr/>
+          <p:nvPr/>
+        </p:nvSpPr>
+        <p:spPr>
+          <a:xfrm>
+            <a:off x="5961888" y="4709160"/>
+            <a:ext cx="2487168" cy="713232"/>
+          </a:xfrm>
+          <a:prstGeom prst="roundRect">
+            <a:avLst/>
+          </a:prstGeom>
+          <a:solidFill>
+            <a:srgbClr val="ECF4F8"/>
+          </a:solidFill>
+          <a:ln>
+            <a:solidFill>
+              <a:srgbClr val="B4CDDB"/>
+            </a:solidFill>
+          </a:ln>
+        </p:spPr>
+        <p:style>
+          <a:lnRef idx="1">
+            <a:schemeClr val="accent1"/>
+          </a:lnRef>
+          <a:fillRef idx="3">
+            <a:schemeClr val="accent1"/>
+          </a:fillRef>
+          <a:effectRef idx="2">
+            <a:schemeClr val="accent1"/>
+          </a:effectRef>
+          <a:fontRef idx="minor">
+            <a:schemeClr val="lt1"/>
+          </a:fontRef>
+        </p:style>
+        <p:txBody>
+          <a:bodyPr rtlCol="0" anchor="ctr"/>
+          <a:lstStyle/>
+          <a:p>
+            <a:pPr algn="ctr"/>
+            <a:r>
+              <a:rPr sz="800" b="0">
+                <a:solidFill>
+                  <a:srgbClr val="195E7F"/>
+                </a:solidFill>
+                <a:latin typeface="Aptos"/>
+              </a:rPr>
+              <a:t>StarUML</a:t>
+            </a:r>
+          </a:p>
+          <a:p>
+            <a:pPr algn="ctr"/>
+            <a:r>
+              <a:rPr sz="800" b="0">
+                <a:solidFill>
+                  <a:srgbClr val="195E7F"/>
+                </a:solidFill>
+                <a:latin typeface="Aptos"/>
+              </a:rPr>
+              <a:t>Entorno de modelado UML</a:t>
+            </a:r>
+          </a:p>
+        </p:txBody>
+      </p:sp>
+      <p:sp>
+        <p:nvSpPr>
+          <p:cNvPr id="25" name="TextBox 24"/>
+          <p:cNvSpPr txBox="1"/>
+          <p:nvPr/>
+        </p:nvSpPr>
+        <p:spPr>
+          <a:xfrm>
+            <a:off x="621792" y="5559552"/>
+            <a:ext cx="7955279" cy="347472"/>
+          </a:xfrm>
+          <a:prstGeom prst="rect">
+            <a:avLst/>
+          </a:prstGeom>
+          <a:noFill/>
+        </p:spPr>
+        <p:txBody>
+          <a:bodyPr wrap="square" anchor="ctr">
+            <a:spAutoFit/>
+          </a:bodyPr>
+          <a:lstStyle/>
+          <a:p>
+            <a:pPr algn="l"/>
+            <a:r>
+              <a:rPr sz="800">
+                <a:solidFill>
+                  <a:srgbClr val="195E7F"/>
+                </a:solidFill>
+                <a:latin typeface="Aptos"/>
+                <a:hlinkClick r:id="rId5"/>
+              </a:rPr>
+              <a:t>OMG, UML 2.5.1</a:t>
+            </a:r>
+            <a:r>
+              <a:rPr sz="800">
+                <a:solidFill>
+                  <a:srgbClr val="4B5963"/>
+                </a:solidFill>
+                <a:latin typeface="Aptos"/>
+              </a:rPr>
+              <a:t> · </a:t>
+            </a:r>
+            <a:r>
+              <a:rPr sz="800">
+                <a:solidFill>
+                  <a:srgbClr val="195E7F"/>
+                </a:solidFill>
+                <a:latin typeface="Aptos"/>
+                <a:hlinkClick r:id="rId6"/>
+              </a:rPr>
+              <a:t>PlantUML, quick start</a:t>
+            </a:r>
+            <a:r>
+              <a:rPr sz="800">
+                <a:solidFill>
+                  <a:srgbClr val="4B5963"/>
+                </a:solidFill>
+                <a:latin typeface="Aptos"/>
+              </a:rPr>
+              <a:t> · </a:t>
+            </a:r>
+            <a:r>
+              <a:rPr sz="800">
+                <a:solidFill>
+                  <a:srgbClr val="195E7F"/>
+                </a:solidFill>
+                <a:latin typeface="Aptos"/>
+                <a:hlinkClick r:id="rId7"/>
+              </a:rPr>
+              <a:t>diagrams.net, UML diagrams</a:t>
+            </a:r>
+            <a:r>
+              <a:rPr sz="800">
+                <a:solidFill>
+                  <a:srgbClr val="4B5963"/>
+                </a:solidFill>
+                <a:latin typeface="Aptos"/>
+              </a:rPr>
+              <a:t> · </a:t>
+            </a:r>
+            <a:r>
+              <a:rPr sz="800">
+                <a:solidFill>
+                  <a:srgbClr val="195E7F"/>
+                </a:solidFill>
+                <a:latin typeface="Aptos"/>
+                <a:hlinkClick r:id="rId4"/>
+              </a:rPr>
+              <a:t>StarUML</a:t>
+            </a:r>
+          </a:p>
+        </p:txBody>
+      </p:sp>
+    </p:spTree>
+  </p:cSld>
+  <p:clrMapOvr>
+    <a:masterClrMapping/>
+  </p:clrMapOvr>
+</p:sld>
+</file>
+
+<file path=ppt/slides/slide9.xml><?xml version="1.0" encoding="utf-8"?>
+<p:sld xmlns:a="http://schemas.openxmlformats.org/drawingml/2006/main" xmlns:p="http://schemas.openxmlformats.org/presentationml/2006/main" xmlns:r="http://schemas.openxmlformats.org/officeDocument/2006/relationships">
+  <p:cSld>
+    <p:spTree>
+      <p:nvGrpSpPr>
+        <p:cNvPr id="1" name=""/>
+        <p:cNvGrpSpPr/>
+        <p:nvPr/>
+      </p:nvGrpSpPr>
+      <p:grpSpPr/>
+      <p:sp>
+        <p:nvSpPr>
+          <p:cNvPr id="2" name="Text Placeholder 1"/>
+          <p:cNvSpPr>
+            <a:spLocks noGrp="1"/>
+          </p:cNvSpPr>
+          <p:nvPr>
+            <p:ph type="body" idx="1"/>
+          </p:nvPr>
+        </p:nvSpPr>
+        <p:spPr/>
+        <p:txBody>
+          <a:bodyPr/>
+          <a:lstStyle/>
+          <a:p/>
+        </p:txBody>
+      </p:sp>
+      <p:sp>
+        <p:nvSpPr>
+          <p:cNvPr id="3" name="Text Placeholder 2"/>
+          <p:cNvSpPr>
+            <a:spLocks noGrp="1"/>
+          </p:cNvSpPr>
+          <p:nvPr>
+            <p:ph type="body" idx="15" sz="quarter"/>
+          </p:nvPr>
+        </p:nvSpPr>
+        <p:spPr/>
+        <p:txBody>
+          <a:bodyPr/>
+          <a:lstStyle/>
+          <a:p/>
+        </p:txBody>
+      </p:sp>
+      <p:sp>
+        <p:nvSpPr>
+          <p:cNvPr id="4" name="TextBox 3"/>
+          <p:cNvSpPr txBox="1"/>
+          <p:nvPr/>
+        </p:nvSpPr>
+        <p:spPr>
+          <a:xfrm>
+            <a:off x="384048" y="164592"/>
+            <a:ext cx="8001000" cy="457200"/>
+          </a:xfrm>
+          <a:prstGeom prst="rect">
+            <a:avLst/>
+          </a:prstGeom>
+          <a:noFill/>
           <a:ln/>
         </p:spPr>
         <p:txBody>
@@ -17837,7 +18925,7 @@
           <a:lstStyle/>
           <a:p>
             <a:r>
-              <a:t>DIGITAL · BIBLIOTECA UCB</a:t>
+              <a:t>LIBRO DIGITAL</a:t>
             </a:r>
           </a:p>
         </p:txBody>
@@ -17976,6 +19064,7 @@
                   <a:srgbClr val="416CBB"/>
                 </a:solidFill>
                 <a:latin typeface="Calibri"/>
+                <a:hlinkClick r:id="rId2"/>
               </a:rPr>
               <a:t>Ver libro digital 1 ↗</a:t>
             </a:r>
@@ -18040,7 +19129,7 @@
           <a:lstStyle/>
           <a:p>
             <a:r>
-              <a:t>DIGITAL · BIBLIOTECA UCB</a:t>
+              <a:t>LIBRO DIGITAL</a:t>
             </a:r>
           </a:p>
         </p:txBody>
@@ -18179,6 +19268,7 @@
                   <a:srgbClr val="416CBB"/>
                 </a:solidFill>
                 <a:latin typeface="Calibri"/>
+                <a:hlinkClick r:id="rId3"/>
               </a:rPr>
               <a:t>Ver libro digital 2 ↗</a:t>
             </a:r>
@@ -18382,6 +19472,7 @@
                   <a:srgbClr val="416CBB"/>
                 </a:solidFill>
                 <a:latin typeface="Calibri"/>
+                <a:hlinkClick r:id="rId7"/>
               </a:rPr>
               <a:t>Consultar ficha bibliográfica ↗</a:t>
             </a:r>
@@ -18412,6 +19503,99 @@
           </a:prstGeom>
         </p:spPr>
       </p:pic>
+      <p:sp>
+        <p:nvSpPr>
+          <p:cNvPr id="23" name="TextBox 22"/>
+          <p:cNvSpPr txBox="1"/>
+          <p:nvPr/>
+        </p:nvSpPr>
+        <p:spPr>
+          <a:xfrm>
+            <a:off x="749808" y="5321808"/>
+            <a:ext cx="7543800" cy="384048"/>
+          </a:xfrm>
+          <a:prstGeom prst="rect">
+            <a:avLst/>
+          </a:prstGeom>
+          <a:noFill/>
+        </p:spPr>
+        <p:txBody>
+          <a:bodyPr wrap="square">
+            <a:spAutoFit/>
+          </a:bodyPr>
+          <a:lstStyle/>
+          <a:p>
+            <a:pPr algn="l"/>
+            <a:r>
+              <a:rPr sz="800">
+                <a:solidFill>
+                  <a:srgbClr val="185274"/>
+                </a:solidFill>
+                <a:latin typeface="Aptos"/>
+                <a:hlinkClick r:id="rId8"/>
+              </a:rPr>
+              <a:t>OMG · UML 2.5.1</a:t>
+            </a:r>
+            <a:r>
+              <a:rPr sz="800">
+                <a:solidFill>
+                  <a:srgbClr val="44525E"/>
+                </a:solidFill>
+                <a:latin typeface="Aptos"/>
+              </a:rPr>
+              <a:t>  ·  </a:t>
+            </a:r>
+            <a:r>
+              <a:rPr sz="800">
+                <a:solidFill>
+                  <a:srgbClr val="185274"/>
+                </a:solidFill>
+                <a:latin typeface="Aptos"/>
+                <a:hlinkClick r:id="rId9"/>
+              </a:rPr>
+              <a:t>PlantUML · Quick start</a:t>
+            </a:r>
+            <a:r>
+              <a:rPr sz="800">
+                <a:solidFill>
+                  <a:srgbClr val="44525E"/>
+                </a:solidFill>
+                <a:latin typeface="Aptos"/>
+              </a:rPr>
+              <a:t>  ·  </a:t>
+            </a:r>
+            <a:r>
+              <a:rPr sz="800">
+                <a:solidFill>
+                  <a:srgbClr val="185274"/>
+                </a:solidFill>
+                <a:latin typeface="Aptos"/>
+                <a:hlinkClick r:id="rId10"/>
+              </a:rPr>
+              <a:t>diagrams.net · UML</a:t>
+            </a:r>
+            <a:r>
+              <a:rPr sz="800">
+                <a:solidFill>
+                  <a:srgbClr val="44525E"/>
+                </a:solidFill>
+                <a:latin typeface="Aptos"/>
+              </a:rPr>
+              <a:t>  ·  </a:t>
+            </a:r>
+            <a:r>
+              <a:rPr sz="800">
+                <a:solidFill>
+                  <a:srgbClr val="185274"/>
+                </a:solidFill>
+                <a:latin typeface="Aptos"/>
+                <a:hlinkClick r:id="rId11"/>
+              </a:rPr>
+              <a:t>StarUML</a:t>
+            </a:r>
+          </a:p>
+        </p:txBody>
+      </p:sp>
     </p:spTree>
   </p:cSld>
   <p:clrMapOvr>

</xml_diff>